<commit_message>
Align ReKindle with the real Baby Trails system
- Add Airtable Bookings adapter and importer; sample data now flows through it
- Journey triggers from estimated baby age (newborn -> baby session, first birthday)
- Opt-in is never inferred from the photo-use Marketing flag; surface eligible count
- No child names, no email, English-only template language, maternity history handled with care
- Approved offer wording counts as covered text; WhatsApp variable rules enforced
- Integration doc with required Baby Trails changes; deck, diagrams and README updated

Co-Authored-By: Claude Sonnet 5.5 <noreply@anthropic.com>
Claude-Session: https://claude.ai/code/session_01VMvtnFmphbhi62SVM5k2E2
</commit_message>
<xml_diff>
--- a/docs/deck/ReKindle_AI_Builder_Cup.pptx
+++ b/docs/deck/ReKindle_AI_Builder_Cup.pptx
@@ -20,6 +20,7 @@
     <p:sldId id="268" r:id="rId19"/>
     <p:sldId id="269" r:id="rId20"/>
     <p:sldId id="270" r:id="rId21"/>
+    <p:sldId id="271" r:id="rId22"/>
   </p:sldIdLst>
   <p:sldSz cx="12191695" cy="6858000" type="screen4x3"/>
   <p:notesSz cx="6858000" cy="9144000"/>
@@ -3400,45 +3401,21 @@
                 </a:solidFill>
                 <a:latin typeface="Arial"/>
               </a:rPr>
-              <a:t>Snapshots of the prototype</a:t>
-            </a:r>
-          </a:p>
-        </p:txBody>
-      </p:sp>
-      <p:pic>
-        <p:nvPicPr>
-          <p:cNvPr id="4" name="Picture 3" descr="cockpit-review.png"/>
-          <p:cNvPicPr>
-            <a:picLocks noChangeAspect="1"/>
-          </p:cNvPicPr>
-          <p:nvPr/>
-        </p:nvPicPr>
-        <p:blipFill>
-          <a:blip r:embed="rId3"/>
-          <a:stretch>
-            <a:fillRect/>
-          </a:stretch>
-        </p:blipFill>
-        <p:spPr>
-          <a:xfrm>
-            <a:off x="363728" y="1371600"/>
-            <a:ext cx="6770624" cy="4480560"/>
-          </a:xfrm>
-          <a:prstGeom prst="rect">
-            <a:avLst/>
-          </a:prstGeom>
-        </p:spPr>
-      </p:pic>
-      <p:sp>
-        <p:nvSpPr>
-          <p:cNvPr id="5" name="TextBox 4"/>
+              <a:t>Estimated implementation cost</a:t>
+            </a:r>
+          </a:p>
+        </p:txBody>
+      </p:sp>
+      <p:sp>
+        <p:nvSpPr>
+          <p:cNvPr id="4" name="TextBox 3"/>
           <p:cNvSpPr txBox="1"/>
           <p:nvPr/>
         </p:nvSpPr>
         <p:spPr>
           <a:xfrm>
-            <a:off x="274320" y="5852160"/>
-            <a:ext cx="6949440" cy="548640"/>
+            <a:off x="457200" y="1417320"/>
+            <a:ext cx="11247120" cy="914400"/>
           </a:xfrm>
           <a:prstGeom prst="rect">
             <a:avLst/>
@@ -3451,60 +3428,36 @@
           </a:bodyPr>
           <a:lstStyle/>
           <a:p>
-            <a:pPr algn="ctr">
-              <a:lnSpc>
-                <a:spcPct val="110000"/>
-              </a:lnSpc>
-              <a:spcAft>
-                <a:spcPts val="585"/>
-              </a:spcAft>
-            </a:pPr>
-            <a:r>
-              <a:rPr sz="1300" b="0">
-                <a:solidFill>
-                  <a:srgbClr val="5B6472"/>
-                </a:solidFill>
-                <a:latin typeface="Arial"/>
-              </a:rPr>
-              <a:t>Owner review queue: claims highlighted against their source facts; autonomy meter shows trust earned</a:t>
-            </a:r>
-          </a:p>
-        </p:txBody>
-      </p:sp>
-      <p:pic>
-        <p:nvPicPr>
-          <p:cNvPr id="6" name="Picture 5" descr="blocked-card.png"/>
-          <p:cNvPicPr>
-            <a:picLocks noChangeAspect="1"/>
-          </p:cNvPicPr>
-          <p:nvPr/>
-        </p:nvPicPr>
-        <p:blipFill>
-          <a:blip r:embed="rId4"/>
-          <a:stretch>
-            <a:fillRect/>
-          </a:stretch>
-        </p:blipFill>
-        <p:spPr>
-          <a:xfrm>
-            <a:off x="7406640" y="2445492"/>
-            <a:ext cx="4526280" cy="2332775"/>
-          </a:xfrm>
-          <a:prstGeom prst="rect">
-            <a:avLst/>
-          </a:prstGeom>
-        </p:spPr>
-      </p:pic>
-      <p:sp>
-        <p:nvSpPr>
-          <p:cNvPr id="7" name="TextBox 6"/>
+            <a:pPr algn="l">
+              <a:lnSpc>
+                <a:spcPct val="110000"/>
+              </a:lnSpc>
+              <a:spcAft>
+                <a:spcPts val="810"/>
+              </a:spcAft>
+            </a:pPr>
+            <a:r>
+              <a:rPr sz="1800" b="0">
+                <a:solidFill>
+                  <a:srgbClr val="14181F"/>
+                </a:solidFill>
+                <a:latin typeface="Arial"/>
+              </a:rPr>
+              <a:t>The MVP runs within Google Cloud hackathon credits. Every cost driver is consumption-based, and the design keeps the expensive part (the LLM) to one call per message, two at most.</a:t>
+            </a:r>
+          </a:p>
+        </p:txBody>
+      </p:sp>
+      <p:sp>
+        <p:nvSpPr>
+          <p:cNvPr id="5" name="TextBox 4"/>
           <p:cNvSpPr txBox="1"/>
           <p:nvPr/>
         </p:nvSpPr>
         <p:spPr>
           <a:xfrm>
-            <a:off x="7406640" y="5852160"/>
-            <a:ext cx="4526280" cy="548640"/>
+            <a:off x="640080" y="2651760"/>
+            <a:ext cx="10789920" cy="3474720"/>
           </a:xfrm>
           <a:prstGeom prst="rect">
             <a:avLst/>
@@ -3517,64 +3470,188 @@
           </a:bodyPr>
           <a:lstStyle/>
           <a:p>
-            <a:pPr algn="ctr">
-              <a:lnSpc>
-                <a:spcPct val="110000"/>
-              </a:lnSpc>
-              <a:spcAft>
-                <a:spcPts val="585"/>
-              </a:spcAft>
-            </a:pPr>
-            <a:r>
-              <a:rPr sz="1300" b="0">
-                <a:solidFill>
-                  <a:srgbClr val="5B6472"/>
-                </a:solidFill>
-                <a:latin typeface="Arial"/>
-              </a:rPr>
-              <a:t>Guardrail at work: an invented 20% discount is blocked and never reaches the customer</a:t>
-            </a:r>
-          </a:p>
-        </p:txBody>
-      </p:sp>
-      <p:sp>
-        <p:nvSpPr>
-          <p:cNvPr id="8" name="TextBox 7"/>
-          <p:cNvSpPr txBox="1"/>
-          <p:nvPr/>
-        </p:nvSpPr>
-        <p:spPr>
-          <a:xfrm>
-            <a:off x="457200" y="6355080"/>
-            <a:ext cx="11247120" cy="365760"/>
-          </a:xfrm>
-          <a:prstGeom prst="rect">
-            <a:avLst/>
-          </a:prstGeom>
-          <a:noFill/>
-        </p:spPr>
-        <p:txBody>
-          <a:bodyPr wrap="square" anchor="t" lIns="45720" rIns="45720" tIns="27432" bIns="27432">
-            <a:spAutoFit/>
-          </a:bodyPr>
-          <a:lstStyle/>
-          <a:p>
             <a:pPr algn="l">
               <a:lnSpc>
                 <a:spcPct val="110000"/>
               </a:lnSpc>
               <a:spcAft>
-                <a:spcPts val="540"/>
-              </a:spcAft>
-            </a:pPr>
-            <a:r>
-              <a:rPr sz="1200" b="0">
-                <a:solidFill>
-                  <a:srgbClr val="5B6472"/>
-                </a:solidFill>
-                <a:latin typeface="Arial"/>
-              </a:rPr>
-              <a:t>Running prototype on synthetic customer data, not real customers.</a:t>
+                <a:spcPts val="950"/>
+              </a:spcAft>
+            </a:pPr>
+            <a:r>
+              <a:rPr sz="1900" b="1">
+                <a:solidFill>
+                  <a:srgbClr val="14181F"/>
+                </a:solidFill>
+                <a:latin typeface="Arial"/>
+              </a:rPr>
+              <a:t>•  </a:t>
+            </a:r>
+            <a:r>
+              <a:rPr sz="1900" b="1">
+                <a:solidFill>
+                  <a:srgbClr val="14181F"/>
+                </a:solidFill>
+                <a:latin typeface="Arial"/>
+              </a:rPr>
+              <a:t>Gemini on Vertex AI: </a:t>
+            </a:r>
+            <a:r>
+              <a:rPr sz="1900" b="0">
+                <a:solidFill>
+                  <a:srgbClr val="14181F"/>
+                </a:solidFill>
+                <a:latin typeface="Arial"/>
+              </a:rPr>
+              <a:t>scales with messages drafted; one call per message, plus one regeneration only when the guardrail blocks a draft</a:t>
+            </a:r>
+          </a:p>
+          <a:p>
+            <a:pPr algn="l">
+              <a:lnSpc>
+                <a:spcPct val="110000"/>
+              </a:lnSpc>
+              <a:spcAft>
+                <a:spcPts val="950"/>
+              </a:spcAft>
+            </a:pPr>
+            <a:r>
+              <a:rPr sz="1900" b="1">
+                <a:solidFill>
+                  <a:srgbClr val="14181F"/>
+                </a:solidFill>
+                <a:latin typeface="Arial"/>
+              </a:rPr>
+              <a:t>•  </a:t>
+            </a:r>
+            <a:r>
+              <a:rPr sz="1900" b="1">
+                <a:solidFill>
+                  <a:srgbClr val="14181F"/>
+                </a:solidFill>
+                <a:latin typeface="Arial"/>
+              </a:rPr>
+              <a:t>BigQuery: </a:t>
+            </a:r>
+            <a:r>
+              <a:rPr sz="1900" b="0">
+                <a:solidFill>
+                  <a:srgbClr val="14181F"/>
+                </a:solidFill>
+                <a:latin typeface="Arial"/>
+              </a:rPr>
+              <a:t>scales with customer records scanned; segmentation is one query per campaign run</a:t>
+            </a:r>
+          </a:p>
+          <a:p>
+            <a:pPr algn="l">
+              <a:lnSpc>
+                <a:spcPct val="110000"/>
+              </a:lnSpc>
+              <a:spcAft>
+                <a:spcPts val="950"/>
+              </a:spcAft>
+            </a:pPr>
+            <a:r>
+              <a:rPr sz="1900" b="1">
+                <a:solidFill>
+                  <a:srgbClr val="14181F"/>
+                </a:solidFill>
+                <a:latin typeface="Arial"/>
+              </a:rPr>
+              <a:t>•  </a:t>
+            </a:r>
+            <a:r>
+              <a:rPr sz="1900" b="1">
+                <a:solidFill>
+                  <a:srgbClr val="14181F"/>
+                </a:solidFill>
+                <a:latin typeface="Arial"/>
+              </a:rPr>
+              <a:t>Cloud Run: </a:t>
+            </a:r>
+            <a:r>
+              <a:rPr sz="1900" b="0">
+                <a:solidFill>
+                  <a:srgbClr val="14181F"/>
+                </a:solidFill>
+                <a:latin typeface="Arial"/>
+              </a:rPr>
+              <a:t>pay-per-request, scales to zero between campaigns</a:t>
+            </a:r>
+          </a:p>
+          <a:p>
+            <a:pPr algn="l">
+              <a:lnSpc>
+                <a:spcPct val="110000"/>
+              </a:lnSpc>
+              <a:spcAft>
+                <a:spcPts val="950"/>
+              </a:spcAft>
+            </a:pPr>
+            <a:r>
+              <a:rPr sz="1900" b="1">
+                <a:solidFill>
+                  <a:srgbClr val="14181F"/>
+                </a:solidFill>
+                <a:latin typeface="Arial"/>
+              </a:rPr>
+              <a:t>•  </a:t>
+            </a:r>
+            <a:r>
+              <a:rPr sz="1900" b="1">
+                <a:solidFill>
+                  <a:srgbClr val="14181F"/>
+                </a:solidFill>
+                <a:latin typeface="Arial"/>
+              </a:rPr>
+              <a:t>Firestore: </a:t>
+            </a:r>
+            <a:r>
+              <a:rPr sz="1900" b="0">
+                <a:solidFill>
+                  <a:srgbClr val="14181F"/>
+                </a:solidFill>
+                <a:latin typeface="Arial"/>
+              </a:rPr>
+              <a:t>scales with cockpit activity (drafts written, decisions made)</a:t>
+            </a:r>
+          </a:p>
+          <a:p>
+            <a:pPr algn="l">
+              <a:lnSpc>
+                <a:spcPct val="110000"/>
+              </a:lnSpc>
+              <a:spcAft>
+                <a:spcPts val="950"/>
+              </a:spcAft>
+            </a:pPr>
+            <a:r>
+              <a:rPr sz="1900" b="1">
+                <a:solidFill>
+                  <a:srgbClr val="14181F"/>
+                </a:solidFill>
+                <a:latin typeface="Arial"/>
+              </a:rPr>
+              <a:t>•  </a:t>
+            </a:r>
+            <a:r>
+              <a:rPr sz="1900" b="1">
+                <a:solidFill>
+                  <a:srgbClr val="14181F"/>
+                </a:solidFill>
+                <a:latin typeface="Arial"/>
+              </a:rPr>
+              <a:t>WhatsApp Business API: </a:t>
+            </a:r>
+            <a:r>
+              <a:rPr sz="1900" b="0">
+                <a:solidFill>
+                  <a:srgbClr val="14181F"/>
+                </a:solidFill>
+                <a:latin typeface="Arial"/>
+              </a:rPr>
+              <a:t>per-conversation fees from the provider; email via Gmail API has no per-message fee</a:t>
             </a:r>
           </a:p>
         </p:txBody>
@@ -3658,57 +3735,35 @@
                 </a:solidFill>
                 <a:latin typeface="Arial"/>
               </a:rPr>
-              <a:t>Prototype performance report / benchmarking</a:t>
-            </a:r>
-          </a:p>
-        </p:txBody>
-      </p:sp>
-      <p:sp>
-        <p:nvSpPr>
-          <p:cNvPr id="4" name="Rounded Rectangle 3"/>
-          <p:cNvSpPr/>
-          <p:nvPr/>
-        </p:nvSpPr>
-        <p:spPr>
-          <a:xfrm>
-            <a:off x="457200" y="1417320"/>
-            <a:ext cx="2651760" cy="1325880"/>
-          </a:xfrm>
-          <a:prstGeom prst="roundRect">
-            <a:avLst>
-              <a:gd name="adj" fmla="val 6000"/>
-            </a:avLst>
-          </a:prstGeom>
-          <a:solidFill>
-            <a:srgbClr val="E7EFFB"/>
-          </a:solidFill>
-          <a:ln>
-            <a:noFill/>
-          </a:ln>
-          <a:effectLst/>
-        </p:spPr>
-        <p:style>
-          <a:lnRef idx="1">
-            <a:schemeClr val="accent1"/>
-          </a:lnRef>
-          <a:fillRef idx="3">
-            <a:schemeClr val="accent1"/>
-          </a:fillRef>
-          <a:effectRef idx="2">
-            <a:schemeClr val="accent1"/>
-          </a:effectRef>
-          <a:fontRef idx="minor">
-            <a:schemeClr val="lt1"/>
-          </a:fontRef>
-        </p:style>
-        <p:txBody>
-          <a:bodyPr rtlCol="0" anchor="ctr"/>
-          <a:lstStyle/>
-          <a:p>
-            <a:pPr algn="ctr"/>
-          </a:p>
-        </p:txBody>
-      </p:sp>
+              <a:t>Snapshots of the prototype</a:t>
+            </a:r>
+          </a:p>
+        </p:txBody>
+      </p:sp>
+      <p:pic>
+        <p:nvPicPr>
+          <p:cNvPr id="4" name="Picture 3" descr="cockpit-review.png"/>
+          <p:cNvPicPr>
+            <a:picLocks noChangeAspect="1"/>
+          </p:cNvPicPr>
+          <p:nvPr/>
+        </p:nvPicPr>
+        <p:blipFill>
+          <a:blip r:embed="rId3"/>
+          <a:stretch>
+            <a:fillRect/>
+          </a:stretch>
+        </p:blipFill>
+        <p:spPr>
+          <a:xfrm>
+            <a:off x="274320" y="1493968"/>
+            <a:ext cx="6400800" cy="4235823"/>
+          </a:xfrm>
+          <a:prstGeom prst="rect">
+            <a:avLst/>
+          </a:prstGeom>
+        </p:spPr>
+      </p:pic>
       <p:sp>
         <p:nvSpPr>
           <p:cNvPr id="5" name="TextBox 4"/>
@@ -3717,8 +3772,8 @@
         </p:nvSpPr>
         <p:spPr>
           <a:xfrm>
-            <a:off x="457200" y="1463040"/>
-            <a:ext cx="2651760" cy="731520"/>
+            <a:off x="274320" y="5852160"/>
+            <a:ext cx="6400800" cy="548640"/>
           </a:xfrm>
           <a:prstGeom prst="rect">
             <a:avLst/>
@@ -3736,31 +3791,55 @@
                 <a:spcPct val="110000"/>
               </a:lnSpc>
               <a:spcAft>
-                <a:spcPts val="1530"/>
-              </a:spcAft>
-            </a:pPr>
-            <a:r>
-              <a:rPr sz="3400" b="1">
-                <a:solidFill>
-                  <a:srgbClr val="14181F"/>
-                </a:solidFill>
-                <a:latin typeface="Arial"/>
-              </a:rPr>
-              <a:t>2,783</a:t>
-            </a:r>
-          </a:p>
-        </p:txBody>
-      </p:sp>
-      <p:sp>
-        <p:nvSpPr>
-          <p:cNvPr id="6" name="TextBox 5"/>
+                <a:spcPts val="585"/>
+              </a:spcAft>
+            </a:pPr>
+            <a:r>
+              <a:rPr sz="1300" b="0">
+                <a:solidFill>
+                  <a:srgbClr val="5B6472"/>
+                </a:solidFill>
+                <a:latin typeface="Arial"/>
+              </a:rPr>
+              <a:t>Owner review queue: claims highlighted against their source facts; autonomy meter shows trust earned</a:t>
+            </a:r>
+          </a:p>
+        </p:txBody>
+      </p:sp>
+      <p:pic>
+        <p:nvPicPr>
+          <p:cNvPr id="6" name="Picture 5" descr="blocked-card.png"/>
+          <p:cNvPicPr>
+            <a:picLocks noChangeAspect="1"/>
+          </p:cNvPicPr>
+          <p:nvPr/>
+        </p:nvPicPr>
+        <p:blipFill>
+          <a:blip r:embed="rId4"/>
+          <a:stretch>
+            <a:fillRect/>
+          </a:stretch>
+        </p:blipFill>
+        <p:spPr>
+          <a:xfrm>
+            <a:off x="6858000" y="2315894"/>
+            <a:ext cx="5029200" cy="2591972"/>
+          </a:xfrm>
+          <a:prstGeom prst="rect">
+            <a:avLst/>
+          </a:prstGeom>
+        </p:spPr>
+      </p:pic>
+      <p:sp>
+        <p:nvSpPr>
+          <p:cNvPr id="7" name="TextBox 6"/>
           <p:cNvSpPr txBox="1"/>
           <p:nvPr/>
         </p:nvSpPr>
         <p:spPr>
           <a:xfrm>
-            <a:off x="548640" y="2194560"/>
-            <a:ext cx="2468880" cy="548640"/>
+            <a:off x="6858000" y="5852160"/>
+            <a:ext cx="5029200" cy="548640"/>
           </a:xfrm>
           <a:prstGeom prst="rect">
             <a:avLst/>
@@ -3784,58 +3863,12 @@
             <a:r>
               <a:rPr sz="1300" b="0">
                 <a:solidFill>
-                  <a:srgbClr val="14181F"/>
-                </a:solidFill>
-                <a:latin typeface="Arial"/>
-              </a:rPr>
-              <a:t>adversarial drafts tested</a:t>
-            </a:r>
-          </a:p>
-        </p:txBody>
-      </p:sp>
-      <p:sp>
-        <p:nvSpPr>
-          <p:cNvPr id="7" name="Rounded Rectangle 6"/>
-          <p:cNvSpPr/>
-          <p:nvPr/>
-        </p:nvSpPr>
-        <p:spPr>
-          <a:xfrm>
-            <a:off x="3291840" y="1417320"/>
-            <a:ext cx="2651760" cy="1325880"/>
-          </a:xfrm>
-          <a:prstGeom prst="roundRect">
-            <a:avLst>
-              <a:gd name="adj" fmla="val 6000"/>
-            </a:avLst>
-          </a:prstGeom>
-          <a:solidFill>
-            <a:srgbClr val="E6F4EA"/>
-          </a:solidFill>
-          <a:ln>
-            <a:noFill/>
-          </a:ln>
-          <a:effectLst/>
-        </p:spPr>
-        <p:style>
-          <a:lnRef idx="1">
-            <a:schemeClr val="accent1"/>
-          </a:lnRef>
-          <a:fillRef idx="3">
-            <a:schemeClr val="accent1"/>
-          </a:fillRef>
-          <a:effectRef idx="2">
-            <a:schemeClr val="accent1"/>
-          </a:effectRef>
-          <a:fontRef idx="minor">
-            <a:schemeClr val="lt1"/>
-          </a:fontRef>
-        </p:style>
-        <p:txBody>
-          <a:bodyPr rtlCol="0" anchor="ctr"/>
-          <a:lstStyle/>
-          <a:p>
-            <a:pPr algn="ctr"/>
+                  <a:srgbClr val="5B6472"/>
+                </a:solidFill>
+                <a:latin typeface="Arial"/>
+              </a:rPr>
+              <a:t>Guardrail at work: an invented 20% discount is blocked and never reaches the customer</a:t>
+            </a:r>
           </a:p>
         </p:txBody>
       </p:sp>
@@ -3847,8 +3880,8 @@
         </p:nvSpPr>
         <p:spPr>
           <a:xfrm>
-            <a:off x="3291840" y="1463040"/>
-            <a:ext cx="2651760" cy="731520"/>
+            <a:off x="457200" y="6355080"/>
+            <a:ext cx="11247120" cy="365760"/>
           </a:xfrm>
           <a:prstGeom prst="rect">
             <a:avLst/>
@@ -3861,528 +3894,22 @@
           </a:bodyPr>
           <a:lstStyle/>
           <a:p>
-            <a:pPr algn="ctr">
-              <a:lnSpc>
-                <a:spcPct val="110000"/>
-              </a:lnSpc>
-              <a:spcAft>
-                <a:spcPts val="1530"/>
-              </a:spcAft>
-            </a:pPr>
-            <a:r>
-              <a:rPr sz="3400" b="1">
-                <a:solidFill>
-                  <a:srgbClr val="14181F"/>
-                </a:solidFill>
-                <a:latin typeface="Arial"/>
-              </a:rPr>
-              <a:t>2,783</a:t>
-            </a:r>
-          </a:p>
-        </p:txBody>
-      </p:sp>
-      <p:sp>
-        <p:nvSpPr>
-          <p:cNvPr id="9" name="TextBox 8"/>
-          <p:cNvSpPr txBox="1"/>
-          <p:nvPr/>
-        </p:nvSpPr>
-        <p:spPr>
-          <a:xfrm>
-            <a:off x="3383280" y="2194560"/>
-            <a:ext cx="2468880" cy="548640"/>
-          </a:xfrm>
-          <a:prstGeom prst="rect">
-            <a:avLst/>
-          </a:prstGeom>
-          <a:noFill/>
-        </p:spPr>
-        <p:txBody>
-          <a:bodyPr wrap="square" anchor="t" lIns="45720" rIns="45720" tIns="27432" bIns="27432">
-            <a:spAutoFit/>
-          </a:bodyPr>
-          <a:lstStyle/>
-          <a:p>
-            <a:pPr algn="ctr">
-              <a:lnSpc>
-                <a:spcPct val="110000"/>
-              </a:lnSpc>
-              <a:spcAft>
-                <a:spcPts val="585"/>
-              </a:spcAft>
-            </a:pPr>
-            <a:r>
-              <a:rPr sz="1300" b="0">
-                <a:solidFill>
-                  <a:srgbClr val="14181F"/>
-                </a:solidFill>
-                <a:latin typeface="Arial"/>
-              </a:rPr>
-              <a:t>stopped by the guardrail</a:t>
-            </a:r>
-          </a:p>
-        </p:txBody>
-      </p:sp>
-      <p:sp>
-        <p:nvSpPr>
-          <p:cNvPr id="10" name="Rounded Rectangle 9"/>
-          <p:cNvSpPr/>
-          <p:nvPr/>
-        </p:nvSpPr>
-        <p:spPr>
-          <a:xfrm>
-            <a:off x="6126480" y="1417320"/>
-            <a:ext cx="2651760" cy="1325880"/>
-          </a:xfrm>
-          <a:prstGeom prst="roundRect">
-            <a:avLst>
-              <a:gd name="adj" fmla="val 6000"/>
-            </a:avLst>
-          </a:prstGeom>
-          <a:solidFill>
-            <a:srgbClr val="E6F4EA"/>
-          </a:solidFill>
-          <a:ln>
-            <a:noFill/>
-          </a:ln>
-          <a:effectLst/>
-        </p:spPr>
-        <p:style>
-          <a:lnRef idx="1">
-            <a:schemeClr val="accent1"/>
-          </a:lnRef>
-          <a:fillRef idx="3">
-            <a:schemeClr val="accent1"/>
-          </a:fillRef>
-          <a:effectRef idx="2">
-            <a:schemeClr val="accent1"/>
-          </a:effectRef>
-          <a:fontRef idx="minor">
-            <a:schemeClr val="lt1"/>
-          </a:fontRef>
-        </p:style>
-        <p:txBody>
-          <a:bodyPr rtlCol="0" anchor="ctr"/>
-          <a:lstStyle/>
-          <a:p>
-            <a:pPr algn="ctr"/>
-          </a:p>
-        </p:txBody>
-      </p:sp>
-      <p:sp>
-        <p:nvSpPr>
-          <p:cNvPr id="11" name="TextBox 10"/>
-          <p:cNvSpPr txBox="1"/>
-          <p:nvPr/>
-        </p:nvSpPr>
-        <p:spPr>
-          <a:xfrm>
-            <a:off x="6126480" y="1463040"/>
-            <a:ext cx="2651760" cy="731520"/>
-          </a:xfrm>
-          <a:prstGeom prst="rect">
-            <a:avLst/>
-          </a:prstGeom>
-          <a:noFill/>
-        </p:spPr>
-        <p:txBody>
-          <a:bodyPr wrap="square" anchor="t" lIns="45720" rIns="45720" tIns="27432" bIns="27432">
-            <a:spAutoFit/>
-          </a:bodyPr>
-          <a:lstStyle/>
-          <a:p>
-            <a:pPr algn="ctr">
-              <a:lnSpc>
-                <a:spcPct val="110000"/>
-              </a:lnSpc>
-              <a:spcAft>
-                <a:spcPts val="1530"/>
-              </a:spcAft>
-            </a:pPr>
-            <a:r>
-              <a:rPr sz="3400" b="1">
-                <a:solidFill>
-                  <a:srgbClr val="14181F"/>
-                </a:solidFill>
-                <a:latin typeface="Arial"/>
-              </a:rPr>
-              <a:t>0</a:t>
-            </a:r>
-          </a:p>
-        </p:txBody>
-      </p:sp>
-      <p:sp>
-        <p:nvSpPr>
-          <p:cNvPr id="12" name="TextBox 11"/>
-          <p:cNvSpPr txBox="1"/>
-          <p:nvPr/>
-        </p:nvSpPr>
-        <p:spPr>
-          <a:xfrm>
-            <a:off x="6217920" y="2194560"/>
-            <a:ext cx="2468880" cy="548640"/>
-          </a:xfrm>
-          <a:prstGeom prst="rect">
-            <a:avLst/>
-          </a:prstGeom>
-          <a:noFill/>
-        </p:spPr>
-        <p:txBody>
-          <a:bodyPr wrap="square" anchor="t" lIns="45720" rIns="45720" tIns="27432" bIns="27432">
-            <a:spAutoFit/>
-          </a:bodyPr>
-          <a:lstStyle/>
-          <a:p>
-            <a:pPr algn="ctr">
-              <a:lnSpc>
-                <a:spcPct val="110000"/>
-              </a:lnSpc>
-              <a:spcAft>
-                <a:spcPts val="585"/>
-              </a:spcAft>
-            </a:pPr>
-            <a:r>
-              <a:rPr sz="1300" b="0">
-                <a:solidFill>
-                  <a:srgbClr val="14181F"/>
-                </a:solidFill>
-                <a:latin typeface="Arial"/>
-              </a:rPr>
-              <a:t>reached a customer without a human</a:t>
-            </a:r>
-          </a:p>
-        </p:txBody>
-      </p:sp>
-      <p:sp>
-        <p:nvSpPr>
-          <p:cNvPr id="13" name="Rounded Rectangle 12"/>
-          <p:cNvSpPr/>
-          <p:nvPr/>
-        </p:nvSpPr>
-        <p:spPr>
-          <a:xfrm>
-            <a:off x="8961120" y="1417320"/>
-            <a:ext cx="2651760" cy="1325880"/>
-          </a:xfrm>
-          <a:prstGeom prst="roundRect">
-            <a:avLst>
-              <a:gd name="adj" fmla="val 6000"/>
-            </a:avLst>
-          </a:prstGeom>
-          <a:solidFill>
-            <a:srgbClr val="E6F4EA"/>
-          </a:solidFill>
-          <a:ln>
-            <a:noFill/>
-          </a:ln>
-          <a:effectLst/>
-        </p:spPr>
-        <p:style>
-          <a:lnRef idx="1">
-            <a:schemeClr val="accent1"/>
-          </a:lnRef>
-          <a:fillRef idx="3">
-            <a:schemeClr val="accent1"/>
-          </a:fillRef>
-          <a:effectRef idx="2">
-            <a:schemeClr val="accent1"/>
-          </a:effectRef>
-          <a:fontRef idx="minor">
-            <a:schemeClr val="lt1"/>
-          </a:fontRef>
-        </p:style>
-        <p:txBody>
-          <a:bodyPr rtlCol="0" anchor="ctr"/>
-          <a:lstStyle/>
-          <a:p>
-            <a:pPr algn="ctr"/>
-          </a:p>
-        </p:txBody>
-      </p:sp>
-      <p:sp>
-        <p:nvSpPr>
-          <p:cNvPr id="14" name="TextBox 13"/>
-          <p:cNvSpPr txBox="1"/>
-          <p:nvPr/>
-        </p:nvSpPr>
-        <p:spPr>
-          <a:xfrm>
-            <a:off x="8961120" y="1463040"/>
-            <a:ext cx="2651760" cy="731520"/>
-          </a:xfrm>
-          <a:prstGeom prst="rect">
-            <a:avLst/>
-          </a:prstGeom>
-          <a:noFill/>
-        </p:spPr>
-        <p:txBody>
-          <a:bodyPr wrap="square" anchor="t" lIns="45720" rIns="45720" tIns="27432" bIns="27432">
-            <a:spAutoFit/>
-          </a:bodyPr>
-          <a:lstStyle/>
-          <a:p>
-            <a:pPr algn="ctr">
-              <a:lnSpc>
-                <a:spcPct val="110000"/>
-              </a:lnSpc>
-              <a:spcAft>
-                <a:spcPts val="1530"/>
-              </a:spcAft>
-            </a:pPr>
-            <a:r>
-              <a:rPr sz="3400" b="1">
-                <a:solidFill>
-                  <a:srgbClr val="14181F"/>
-                </a:solidFill>
-                <a:latin typeface="Arial"/>
-              </a:rPr>
-              <a:t>0%</a:t>
-            </a:r>
-          </a:p>
-        </p:txBody>
-      </p:sp>
-      <p:sp>
-        <p:nvSpPr>
-          <p:cNvPr id="15" name="TextBox 14"/>
-          <p:cNvSpPr txBox="1"/>
-          <p:nvPr/>
-        </p:nvSpPr>
-        <p:spPr>
-          <a:xfrm>
-            <a:off x="9052560" y="2194560"/>
-            <a:ext cx="2468880" cy="548640"/>
-          </a:xfrm>
-          <a:prstGeom prst="rect">
-            <a:avLst/>
-          </a:prstGeom>
-          <a:noFill/>
-        </p:spPr>
-        <p:txBody>
-          <a:bodyPr wrap="square" anchor="t" lIns="45720" rIns="45720" tIns="27432" bIns="27432">
-            <a:spAutoFit/>
-          </a:bodyPr>
-          <a:lstStyle/>
-          <a:p>
-            <a:pPr algn="ctr">
-              <a:lnSpc>
-                <a:spcPct val="110000"/>
-              </a:lnSpc>
-              <a:spcAft>
-                <a:spcPts val="585"/>
-              </a:spcAft>
-            </a:pPr>
-            <a:r>
-              <a:rPr sz="1300" b="0">
-                <a:solidFill>
-                  <a:srgbClr val="14181F"/>
-                </a:solidFill>
-                <a:latin typeface="Arial"/>
-              </a:rPr>
-              <a:t>good drafts wrongly blocked</a:t>
-            </a:r>
-          </a:p>
-        </p:txBody>
-      </p:sp>
-      <p:sp>
-        <p:nvSpPr>
-          <p:cNvPr id="16" name="TextBox 15"/>
-          <p:cNvSpPr txBox="1"/>
-          <p:nvPr/>
-        </p:nvSpPr>
-        <p:spPr>
-          <a:xfrm>
-            <a:off x="457200" y="2926080"/>
-            <a:ext cx="11247120" cy="2377440"/>
-          </a:xfrm>
-          <a:prstGeom prst="rect">
-            <a:avLst/>
-          </a:prstGeom>
-          <a:noFill/>
-        </p:spPr>
-        <p:txBody>
-          <a:bodyPr wrap="square" anchor="t" lIns="45720" rIns="45720" tIns="27432" bIns="27432">
-            <a:spAutoFit/>
-          </a:bodyPr>
-          <a:lstStyle/>
-          <a:p>
             <a:pPr algn="l">
               <a:lnSpc>
                 <a:spcPct val="110000"/>
               </a:lnSpc>
               <a:spcAft>
-                <a:spcPts val="640"/>
-              </a:spcAft>
-            </a:pPr>
-            <a:r>
-              <a:rPr sz="1600" b="1">
-                <a:solidFill>
-                  <a:srgbClr val="14181F"/>
-                </a:solidFill>
-                <a:latin typeface="Arial"/>
-              </a:rPr>
-              <a:t>•  </a:t>
-            </a:r>
-            <a:r>
-              <a:rPr sz="1600" b="0">
-                <a:solidFill>
-                  <a:srgbClr val="14181F"/>
-                </a:solidFill>
-                <a:latin typeface="Arial"/>
-              </a:rPr>
-              <a:t>12 corruption types a hallucinating model could produce (invented discount, wrong age, invented name, fake product, pressure, links, guarantees, fabricated memories) applied to all 233 outreach targets, with auto-send fully unlocked and the threshold at its floor.</a:t>
-            </a:r>
-          </a:p>
-          <a:p>
-            <a:pPr algn="l">
-              <a:lnSpc>
-                <a:spcPct val="110000"/>
-              </a:lnSpc>
-              <a:spcAft>
-                <a:spcPts val="640"/>
-              </a:spcAft>
-            </a:pPr>
-            <a:r>
-              <a:rPr sz="1600" b="1">
-                <a:solidFill>
-                  <a:srgbClr val="14181F"/>
-                </a:solidFill>
-                <a:latin typeface="Arial"/>
-              </a:rPr>
-              <a:t>•  </a:t>
-            </a:r>
-            <a:r>
-              <a:rPr sz="1600" b="0">
-                <a:solidFill>
-                  <a:srgbClr val="14181F"/>
-                </a:solidFill>
-                <a:latin typeface="Arial"/>
-              </a:rPr>
-              <a:t>Seeded demo run (synthetic, 320 customers): 90 drafts, 43 sent (21 auto-sent, 22 owner-approved), 4 blocked, 2 opt-outs honoured. Owner decisions, replies and orders in this run are simulated.</a:t>
-            </a:r>
-          </a:p>
-          <a:p>
-            <a:pPr algn="l">
-              <a:lnSpc>
-                <a:spcPct val="110000"/>
-              </a:lnSpc>
-              <a:spcAft>
-                <a:spcPts val="640"/>
-              </a:spcAft>
-            </a:pPr>
-            <a:r>
-              <a:rPr sz="1600" b="1">
-                <a:solidFill>
-                  <a:srgbClr val="14181F"/>
-                </a:solidFill>
-                <a:latin typeface="Arial"/>
-              </a:rPr>
-              <a:t>•  </a:t>
-            </a:r>
-            <a:r>
-              <a:rPr sz="1600" b="0">
-                <a:solidFill>
-                  <a:srgbClr val="14181F"/>
-                </a:solidFill>
-                <a:latin typeface="Arial"/>
-              </a:rPr>
-              <a:t>49 automated tests cover segmentation, consent and STOP in several languages, the guardrail, routing and the approval API.</a:t>
-            </a:r>
-          </a:p>
-        </p:txBody>
-      </p:sp>
-      <p:sp>
-        <p:nvSpPr>
-          <p:cNvPr id="17" name="Rounded Rectangle 16"/>
-          <p:cNvSpPr/>
-          <p:nvPr/>
-        </p:nvSpPr>
-        <p:spPr>
-          <a:xfrm>
-            <a:off x="457200" y="5257800"/>
-            <a:ext cx="11247120" cy="1280160"/>
-          </a:xfrm>
-          <a:prstGeom prst="roundRect">
-            <a:avLst>
-              <a:gd name="adj" fmla="val 6000"/>
-            </a:avLst>
-          </a:prstGeom>
-          <a:solidFill>
-            <a:srgbClr val="FDE8E6"/>
-          </a:solidFill>
-          <a:ln>
-            <a:noFill/>
-          </a:ln>
-          <a:effectLst/>
-        </p:spPr>
-        <p:style>
-          <a:lnRef idx="1">
-            <a:schemeClr val="accent1"/>
-          </a:lnRef>
-          <a:fillRef idx="3">
-            <a:schemeClr val="accent1"/>
-          </a:fillRef>
-          <a:effectRef idx="2">
-            <a:schemeClr val="accent1"/>
-          </a:effectRef>
-          <a:fontRef idx="minor">
-            <a:schemeClr val="lt1"/>
-          </a:fontRef>
-        </p:style>
-        <p:txBody>
-          <a:bodyPr rtlCol="0" anchor="ctr"/>
-          <a:lstStyle/>
-          <a:p>
-            <a:pPr algn="ctr"/>
-          </a:p>
-        </p:txBody>
-      </p:sp>
-      <p:sp>
-        <p:nvSpPr>
-          <p:cNvPr id="18" name="TextBox 17"/>
-          <p:cNvSpPr txBox="1"/>
-          <p:nvPr/>
-        </p:nvSpPr>
-        <p:spPr>
-          <a:xfrm>
-            <a:off x="640080" y="5303520"/>
-            <a:ext cx="10881360" cy="1234440"/>
-          </a:xfrm>
-          <a:prstGeom prst="rect">
-            <a:avLst/>
-          </a:prstGeom>
-          <a:noFill/>
-        </p:spPr>
-        <p:txBody>
-          <a:bodyPr wrap="square" anchor="t" lIns="45720" rIns="45720" tIns="27432" bIns="27432">
-            <a:spAutoFit/>
-          </a:bodyPr>
-          <a:lstStyle/>
-          <a:p>
-            <a:pPr algn="l">
-              <a:lnSpc>
-                <a:spcPct val="110000"/>
-              </a:lnSpc>
-              <a:spcAft>
-                <a:spcPts val="630"/>
-              </a:spcAft>
-            </a:pPr>
-            <a:r>
-              <a:rPr sz="1400" b="1">
-                <a:solidFill>
-                  <a:srgbClr val="14181F"/>
-                </a:solidFill>
-                <a:latin typeface="Arial"/>
-              </a:rPr>
-              <a:t>Honest scope. </a:t>
-            </a:r>
-            <a:r>
-              <a:rPr sz="1400" b="0">
-                <a:solidFill>
-                  <a:srgbClr val="14181F"/>
-                </a:solidFill>
-                <a:latin typeface="Arial"/>
-              </a:rPr>
-              <a:t>This tests the guardrail with our own corruption set on synthetic data, not Gemini's real output or real customers. Pilot metrics (auto-send rate, approval latency, time saved, recovered revenue) will be measured on Babytrail's data at the Nov 6 prototype evaluation and replace the simulated figures.</a:t>
+                <a:spcPts val="540"/>
+              </a:spcAft>
+            </a:pPr>
+            <a:r>
+              <a:rPr sz="1200" b="0">
+                <a:solidFill>
+                  <a:srgbClr val="5B6472"/>
+                </a:solidFill>
+                <a:latin typeface="Arial"/>
+              </a:rPr>
+              <a:t>Running prototype on synthetic customer data, not real customers.</a:t>
             </a:r>
           </a:p>
         </p:txBody>
@@ -4466,21 +3993,67 @@
                 </a:solidFill>
                 <a:latin typeface="Arial"/>
               </a:rPr>
-              <a:t>Additional details / future development</a:t>
-            </a:r>
-          </a:p>
-        </p:txBody>
-      </p:sp>
-      <p:sp>
-        <p:nvSpPr>
-          <p:cNvPr id="4" name="TextBox 3"/>
+              <a:t>Prototype performance report / benchmarking</a:t>
+            </a:r>
+          </a:p>
+        </p:txBody>
+      </p:sp>
+      <p:sp>
+        <p:nvSpPr>
+          <p:cNvPr id="4" name="Rounded Rectangle 3"/>
+          <p:cNvSpPr/>
+          <p:nvPr/>
+        </p:nvSpPr>
+        <p:spPr>
+          <a:xfrm>
+            <a:off x="457200" y="1417320"/>
+            <a:ext cx="2651760" cy="1325880"/>
+          </a:xfrm>
+          <a:prstGeom prst="roundRect">
+            <a:avLst>
+              <a:gd name="adj" fmla="val 6000"/>
+            </a:avLst>
+          </a:prstGeom>
+          <a:solidFill>
+            <a:srgbClr val="E7EFFB"/>
+          </a:solidFill>
+          <a:ln>
+            <a:noFill/>
+          </a:ln>
+          <a:effectLst/>
+        </p:spPr>
+        <p:style>
+          <a:lnRef idx="1">
+            <a:schemeClr val="accent1"/>
+          </a:lnRef>
+          <a:fillRef idx="3">
+            <a:schemeClr val="accent1"/>
+          </a:fillRef>
+          <a:effectRef idx="2">
+            <a:schemeClr val="accent1"/>
+          </a:effectRef>
+          <a:fontRef idx="minor">
+            <a:schemeClr val="lt1"/>
+          </a:fontRef>
+        </p:style>
+        <p:txBody>
+          <a:bodyPr rtlCol="0" anchor="ctr"/>
+          <a:lstStyle/>
+          <a:p>
+            <a:pPr algn="ctr"/>
+          </a:p>
+        </p:txBody>
+      </p:sp>
+      <p:sp>
+        <p:nvSpPr>
+          <p:cNvPr id="5" name="TextBox 4"/>
           <p:cNvSpPr txBox="1"/>
           <p:nvPr/>
         </p:nvSpPr>
         <p:spPr>
           <a:xfrm>
-            <a:off x="548640" y="1463040"/>
-            <a:ext cx="11064240" cy="4937760"/>
+            <a:off x="457200" y="1463040"/>
+            <a:ext cx="2651760" cy="731520"/>
           </a:xfrm>
           <a:prstGeom prst="rect">
             <a:avLst/>
@@ -4493,16 +4066,490 @@
           </a:bodyPr>
           <a:lstStyle/>
           <a:p>
+            <a:pPr algn="ctr">
+              <a:lnSpc>
+                <a:spcPct val="110000"/>
+              </a:lnSpc>
+              <a:spcAft>
+                <a:spcPts val="1530"/>
+              </a:spcAft>
+            </a:pPr>
+            <a:r>
+              <a:rPr sz="3400" b="1">
+                <a:solidFill>
+                  <a:srgbClr val="14181F"/>
+                </a:solidFill>
+                <a:latin typeface="Arial"/>
+              </a:rPr>
+              <a:t>1,864</a:t>
+            </a:r>
+          </a:p>
+        </p:txBody>
+      </p:sp>
+      <p:sp>
+        <p:nvSpPr>
+          <p:cNvPr id="6" name="TextBox 5"/>
+          <p:cNvSpPr txBox="1"/>
+          <p:nvPr/>
+        </p:nvSpPr>
+        <p:spPr>
+          <a:xfrm>
+            <a:off x="548640" y="2194560"/>
+            <a:ext cx="2468880" cy="548640"/>
+          </a:xfrm>
+          <a:prstGeom prst="rect">
+            <a:avLst/>
+          </a:prstGeom>
+          <a:noFill/>
+        </p:spPr>
+        <p:txBody>
+          <a:bodyPr wrap="square" anchor="t" lIns="45720" rIns="45720" tIns="27432" bIns="27432">
+            <a:spAutoFit/>
+          </a:bodyPr>
+          <a:lstStyle/>
+          <a:p>
+            <a:pPr algn="ctr">
+              <a:lnSpc>
+                <a:spcPct val="110000"/>
+              </a:lnSpc>
+              <a:spcAft>
+                <a:spcPts val="585"/>
+              </a:spcAft>
+            </a:pPr>
+            <a:r>
+              <a:rPr sz="1300" b="0">
+                <a:solidFill>
+                  <a:srgbClr val="14181F"/>
+                </a:solidFill>
+                <a:latin typeface="Arial"/>
+              </a:rPr>
+              <a:t>adversarial drafts tested</a:t>
+            </a:r>
+          </a:p>
+        </p:txBody>
+      </p:sp>
+      <p:sp>
+        <p:nvSpPr>
+          <p:cNvPr id="7" name="Rounded Rectangle 6"/>
+          <p:cNvSpPr/>
+          <p:nvPr/>
+        </p:nvSpPr>
+        <p:spPr>
+          <a:xfrm>
+            <a:off x="3291840" y="1417320"/>
+            <a:ext cx="2651760" cy="1325880"/>
+          </a:xfrm>
+          <a:prstGeom prst="roundRect">
+            <a:avLst>
+              <a:gd name="adj" fmla="val 6000"/>
+            </a:avLst>
+          </a:prstGeom>
+          <a:solidFill>
+            <a:srgbClr val="E6F4EA"/>
+          </a:solidFill>
+          <a:ln>
+            <a:noFill/>
+          </a:ln>
+          <a:effectLst/>
+        </p:spPr>
+        <p:style>
+          <a:lnRef idx="1">
+            <a:schemeClr val="accent1"/>
+          </a:lnRef>
+          <a:fillRef idx="3">
+            <a:schemeClr val="accent1"/>
+          </a:fillRef>
+          <a:effectRef idx="2">
+            <a:schemeClr val="accent1"/>
+          </a:effectRef>
+          <a:fontRef idx="minor">
+            <a:schemeClr val="lt1"/>
+          </a:fontRef>
+        </p:style>
+        <p:txBody>
+          <a:bodyPr rtlCol="0" anchor="ctr"/>
+          <a:lstStyle/>
+          <a:p>
+            <a:pPr algn="ctr"/>
+          </a:p>
+        </p:txBody>
+      </p:sp>
+      <p:sp>
+        <p:nvSpPr>
+          <p:cNvPr id="8" name="TextBox 7"/>
+          <p:cNvSpPr txBox="1"/>
+          <p:nvPr/>
+        </p:nvSpPr>
+        <p:spPr>
+          <a:xfrm>
+            <a:off x="3291840" y="1463040"/>
+            <a:ext cx="2651760" cy="731520"/>
+          </a:xfrm>
+          <a:prstGeom prst="rect">
+            <a:avLst/>
+          </a:prstGeom>
+          <a:noFill/>
+        </p:spPr>
+        <p:txBody>
+          <a:bodyPr wrap="square" anchor="t" lIns="45720" rIns="45720" tIns="27432" bIns="27432">
+            <a:spAutoFit/>
+          </a:bodyPr>
+          <a:lstStyle/>
+          <a:p>
+            <a:pPr algn="ctr">
+              <a:lnSpc>
+                <a:spcPct val="110000"/>
+              </a:lnSpc>
+              <a:spcAft>
+                <a:spcPts val="1530"/>
+              </a:spcAft>
+            </a:pPr>
+            <a:r>
+              <a:rPr sz="3400" b="1">
+                <a:solidFill>
+                  <a:srgbClr val="14181F"/>
+                </a:solidFill>
+                <a:latin typeface="Arial"/>
+              </a:rPr>
+              <a:t>1,864</a:t>
+            </a:r>
+          </a:p>
+        </p:txBody>
+      </p:sp>
+      <p:sp>
+        <p:nvSpPr>
+          <p:cNvPr id="9" name="TextBox 8"/>
+          <p:cNvSpPr txBox="1"/>
+          <p:nvPr/>
+        </p:nvSpPr>
+        <p:spPr>
+          <a:xfrm>
+            <a:off x="3383280" y="2194560"/>
+            <a:ext cx="2468880" cy="548640"/>
+          </a:xfrm>
+          <a:prstGeom prst="rect">
+            <a:avLst/>
+          </a:prstGeom>
+          <a:noFill/>
+        </p:spPr>
+        <p:txBody>
+          <a:bodyPr wrap="square" anchor="t" lIns="45720" rIns="45720" tIns="27432" bIns="27432">
+            <a:spAutoFit/>
+          </a:bodyPr>
+          <a:lstStyle/>
+          <a:p>
+            <a:pPr algn="ctr">
+              <a:lnSpc>
+                <a:spcPct val="110000"/>
+              </a:lnSpc>
+              <a:spcAft>
+                <a:spcPts val="585"/>
+              </a:spcAft>
+            </a:pPr>
+            <a:r>
+              <a:rPr sz="1300" b="0">
+                <a:solidFill>
+                  <a:srgbClr val="14181F"/>
+                </a:solidFill>
+                <a:latin typeface="Arial"/>
+              </a:rPr>
+              <a:t>stopped by the guardrail</a:t>
+            </a:r>
+          </a:p>
+        </p:txBody>
+      </p:sp>
+      <p:sp>
+        <p:nvSpPr>
+          <p:cNvPr id="10" name="Rounded Rectangle 9"/>
+          <p:cNvSpPr/>
+          <p:nvPr/>
+        </p:nvSpPr>
+        <p:spPr>
+          <a:xfrm>
+            <a:off x="6126480" y="1417320"/>
+            <a:ext cx="2651760" cy="1325880"/>
+          </a:xfrm>
+          <a:prstGeom prst="roundRect">
+            <a:avLst>
+              <a:gd name="adj" fmla="val 6000"/>
+            </a:avLst>
+          </a:prstGeom>
+          <a:solidFill>
+            <a:srgbClr val="E6F4EA"/>
+          </a:solidFill>
+          <a:ln>
+            <a:noFill/>
+          </a:ln>
+          <a:effectLst/>
+        </p:spPr>
+        <p:style>
+          <a:lnRef idx="1">
+            <a:schemeClr val="accent1"/>
+          </a:lnRef>
+          <a:fillRef idx="3">
+            <a:schemeClr val="accent1"/>
+          </a:fillRef>
+          <a:effectRef idx="2">
+            <a:schemeClr val="accent1"/>
+          </a:effectRef>
+          <a:fontRef idx="minor">
+            <a:schemeClr val="lt1"/>
+          </a:fontRef>
+        </p:style>
+        <p:txBody>
+          <a:bodyPr rtlCol="0" anchor="ctr"/>
+          <a:lstStyle/>
+          <a:p>
+            <a:pPr algn="ctr"/>
+          </a:p>
+        </p:txBody>
+      </p:sp>
+      <p:sp>
+        <p:nvSpPr>
+          <p:cNvPr id="11" name="TextBox 10"/>
+          <p:cNvSpPr txBox="1"/>
+          <p:nvPr/>
+        </p:nvSpPr>
+        <p:spPr>
+          <a:xfrm>
+            <a:off x="6126480" y="1463040"/>
+            <a:ext cx="2651760" cy="731520"/>
+          </a:xfrm>
+          <a:prstGeom prst="rect">
+            <a:avLst/>
+          </a:prstGeom>
+          <a:noFill/>
+        </p:spPr>
+        <p:txBody>
+          <a:bodyPr wrap="square" anchor="t" lIns="45720" rIns="45720" tIns="27432" bIns="27432">
+            <a:spAutoFit/>
+          </a:bodyPr>
+          <a:lstStyle/>
+          <a:p>
+            <a:pPr algn="ctr">
+              <a:lnSpc>
+                <a:spcPct val="110000"/>
+              </a:lnSpc>
+              <a:spcAft>
+                <a:spcPts val="1530"/>
+              </a:spcAft>
+            </a:pPr>
+            <a:r>
+              <a:rPr sz="3400" b="1">
+                <a:solidFill>
+                  <a:srgbClr val="14181F"/>
+                </a:solidFill>
+                <a:latin typeface="Arial"/>
+              </a:rPr>
+              <a:t>0</a:t>
+            </a:r>
+          </a:p>
+        </p:txBody>
+      </p:sp>
+      <p:sp>
+        <p:nvSpPr>
+          <p:cNvPr id="12" name="TextBox 11"/>
+          <p:cNvSpPr txBox="1"/>
+          <p:nvPr/>
+        </p:nvSpPr>
+        <p:spPr>
+          <a:xfrm>
+            <a:off x="6217920" y="2194560"/>
+            <a:ext cx="2468880" cy="548640"/>
+          </a:xfrm>
+          <a:prstGeom prst="rect">
+            <a:avLst/>
+          </a:prstGeom>
+          <a:noFill/>
+        </p:spPr>
+        <p:txBody>
+          <a:bodyPr wrap="square" anchor="t" lIns="45720" rIns="45720" tIns="27432" bIns="27432">
+            <a:spAutoFit/>
+          </a:bodyPr>
+          <a:lstStyle/>
+          <a:p>
+            <a:pPr algn="ctr">
+              <a:lnSpc>
+                <a:spcPct val="110000"/>
+              </a:lnSpc>
+              <a:spcAft>
+                <a:spcPts val="585"/>
+              </a:spcAft>
+            </a:pPr>
+            <a:r>
+              <a:rPr sz="1300" b="0">
+                <a:solidFill>
+                  <a:srgbClr val="14181F"/>
+                </a:solidFill>
+                <a:latin typeface="Arial"/>
+              </a:rPr>
+              <a:t>reached a customer without a human</a:t>
+            </a:r>
+          </a:p>
+        </p:txBody>
+      </p:sp>
+      <p:sp>
+        <p:nvSpPr>
+          <p:cNvPr id="13" name="Rounded Rectangle 12"/>
+          <p:cNvSpPr/>
+          <p:nvPr/>
+        </p:nvSpPr>
+        <p:spPr>
+          <a:xfrm>
+            <a:off x="8961120" y="1417320"/>
+            <a:ext cx="2651760" cy="1325880"/>
+          </a:xfrm>
+          <a:prstGeom prst="roundRect">
+            <a:avLst>
+              <a:gd name="adj" fmla="val 6000"/>
+            </a:avLst>
+          </a:prstGeom>
+          <a:solidFill>
+            <a:srgbClr val="E6F4EA"/>
+          </a:solidFill>
+          <a:ln>
+            <a:noFill/>
+          </a:ln>
+          <a:effectLst/>
+        </p:spPr>
+        <p:style>
+          <a:lnRef idx="1">
+            <a:schemeClr val="accent1"/>
+          </a:lnRef>
+          <a:fillRef idx="3">
+            <a:schemeClr val="accent1"/>
+          </a:fillRef>
+          <a:effectRef idx="2">
+            <a:schemeClr val="accent1"/>
+          </a:effectRef>
+          <a:fontRef idx="minor">
+            <a:schemeClr val="lt1"/>
+          </a:fontRef>
+        </p:style>
+        <p:txBody>
+          <a:bodyPr rtlCol="0" anchor="ctr"/>
+          <a:lstStyle/>
+          <a:p>
+            <a:pPr algn="ctr"/>
+          </a:p>
+        </p:txBody>
+      </p:sp>
+      <p:sp>
+        <p:nvSpPr>
+          <p:cNvPr id="14" name="TextBox 13"/>
+          <p:cNvSpPr txBox="1"/>
+          <p:nvPr/>
+        </p:nvSpPr>
+        <p:spPr>
+          <a:xfrm>
+            <a:off x="8961120" y="1463040"/>
+            <a:ext cx="2651760" cy="731520"/>
+          </a:xfrm>
+          <a:prstGeom prst="rect">
+            <a:avLst/>
+          </a:prstGeom>
+          <a:noFill/>
+        </p:spPr>
+        <p:txBody>
+          <a:bodyPr wrap="square" anchor="t" lIns="45720" rIns="45720" tIns="27432" bIns="27432">
+            <a:spAutoFit/>
+          </a:bodyPr>
+          <a:lstStyle/>
+          <a:p>
+            <a:pPr algn="ctr">
+              <a:lnSpc>
+                <a:spcPct val="110000"/>
+              </a:lnSpc>
+              <a:spcAft>
+                <a:spcPts val="1530"/>
+              </a:spcAft>
+            </a:pPr>
+            <a:r>
+              <a:rPr sz="3400" b="1">
+                <a:solidFill>
+                  <a:srgbClr val="14181F"/>
+                </a:solidFill>
+                <a:latin typeface="Arial"/>
+              </a:rPr>
+              <a:t>0%</a:t>
+            </a:r>
+          </a:p>
+        </p:txBody>
+      </p:sp>
+      <p:sp>
+        <p:nvSpPr>
+          <p:cNvPr id="15" name="TextBox 14"/>
+          <p:cNvSpPr txBox="1"/>
+          <p:nvPr/>
+        </p:nvSpPr>
+        <p:spPr>
+          <a:xfrm>
+            <a:off x="9052560" y="2194560"/>
+            <a:ext cx="2468880" cy="548640"/>
+          </a:xfrm>
+          <a:prstGeom prst="rect">
+            <a:avLst/>
+          </a:prstGeom>
+          <a:noFill/>
+        </p:spPr>
+        <p:txBody>
+          <a:bodyPr wrap="square" anchor="t" lIns="45720" rIns="45720" tIns="27432" bIns="27432">
+            <a:spAutoFit/>
+          </a:bodyPr>
+          <a:lstStyle/>
+          <a:p>
+            <a:pPr algn="ctr">
+              <a:lnSpc>
+                <a:spcPct val="110000"/>
+              </a:lnSpc>
+              <a:spcAft>
+                <a:spcPts val="585"/>
+              </a:spcAft>
+            </a:pPr>
+            <a:r>
+              <a:rPr sz="1300" b="0">
+                <a:solidFill>
+                  <a:srgbClr val="14181F"/>
+                </a:solidFill>
+                <a:latin typeface="Arial"/>
+              </a:rPr>
+              <a:t>good drafts wrongly blocked</a:t>
+            </a:r>
+          </a:p>
+        </p:txBody>
+      </p:sp>
+      <p:sp>
+        <p:nvSpPr>
+          <p:cNvPr id="16" name="TextBox 15"/>
+          <p:cNvSpPr txBox="1"/>
+          <p:nvPr/>
+        </p:nvSpPr>
+        <p:spPr>
+          <a:xfrm>
+            <a:off x="457200" y="2926080"/>
+            <a:ext cx="11247120" cy="2377440"/>
+          </a:xfrm>
+          <a:prstGeom prst="rect">
+            <a:avLst/>
+          </a:prstGeom>
+          <a:noFill/>
+        </p:spPr>
+        <p:txBody>
+          <a:bodyPr wrap="square" anchor="t" lIns="45720" rIns="45720" tIns="27432" bIns="27432">
+            <a:spAutoFit/>
+          </a:bodyPr>
+          <a:lstStyle/>
+          <a:p>
             <a:pPr algn="l">
               <a:lnSpc>
                 <a:spcPct val="110000"/>
               </a:lnSpc>
               <a:spcAft>
-                <a:spcPts val="1080"/>
-              </a:spcAft>
-            </a:pPr>
-            <a:r>
-              <a:rPr sz="1800" b="1">
+                <a:spcPts val="450"/>
+              </a:spcAft>
+            </a:pPr>
+            <a:r>
+              <a:rPr sz="1500" b="1">
                 <a:solidFill>
                   <a:srgbClr val="14181F"/>
                 </a:solidFill>
@@ -4511,22 +4558,13 @@
               <a:t>•  </a:t>
             </a:r>
             <a:r>
-              <a:rPr sz="1800" b="1">
-                <a:solidFill>
-                  <a:srgbClr val="14181F"/>
-                </a:solidFill>
-                <a:latin typeface="Arial"/>
-              </a:rPr>
-              <a:t>Second-layer semantic verifier: </a:t>
-            </a:r>
-            <a:r>
-              <a:rPr sz="1800" b="0">
-                <a:solidFill>
-                  <a:srgbClr val="14181F"/>
-                </a:solidFill>
-                <a:latin typeface="Arial"/>
-              </a:rPr>
-              <a:t>a Gemini entailment check on top of the deterministic one, for paraphrased claims no rule can see</a:t>
+              <a:rPr sz="1500" b="0">
+                <a:solidFill>
+                  <a:srgbClr val="14181F"/>
+                </a:solidFill>
+                <a:latin typeface="Arial"/>
+              </a:rPr>
+              <a:t>13 corruption types a hallucinating model could produce (invented discount, wrong age, invented name, fake product, pressure, links, guarantees, fabricated memories) applied to all 145 outreach targets, with auto-send fully unlocked and the threshold at its floor.</a:t>
             </a:r>
           </a:p>
           <a:p>
@@ -4535,11 +4573,11 @@
                 <a:spcPct val="110000"/>
               </a:lnSpc>
               <a:spcAft>
-                <a:spcPts val="1080"/>
-              </a:spcAft>
-            </a:pPr>
-            <a:r>
-              <a:rPr sz="1800" b="1">
+                <a:spcPts val="450"/>
+              </a:spcAft>
+            </a:pPr>
+            <a:r>
+              <a:rPr sz="1500" b="1">
                 <a:solidFill>
                   <a:srgbClr val="14181F"/>
                 </a:solidFill>
@@ -4548,22 +4586,13 @@
               <a:t>•  </a:t>
             </a:r>
             <a:r>
-              <a:rPr sz="1800" b="1">
-                <a:solidFill>
-                  <a:srgbClr val="14181F"/>
-                </a:solidFill>
-                <a:latin typeface="Arial"/>
-              </a:rPr>
-              <a:t>Native integrations: </a:t>
-            </a:r>
-            <a:r>
-              <a:rPr sz="1800" b="0">
-                <a:solidFill>
-                  <a:srgbClr val="14181F"/>
-                </a:solidFill>
-                <a:latin typeface="Arial"/>
-              </a:rPr>
-              <a:t>Shopify, WooCommerce and Unicommerce for one-click onboarding</a:t>
+              <a:rPr sz="1500" b="0">
+                <a:solidFill>
+                  <a:srgbClr val="14181F"/>
+                </a:solidFill>
+                <a:latin typeface="Arial"/>
+              </a:rPr>
+              <a:t>Seeded demo run on synthetic Baby Trails-shaped data (320 customers, 176 opted in): 90 drafts, 29 sent (7 auto-sent, 22 owner-approved), 7 blocked, 2 opt-outs honoured. Owner decisions, replies and orders are simulated; the opt-in rate is illustrative.</a:t>
             </a:r>
           </a:p>
           <a:p>
@@ -4572,11 +4601,11 @@
                 <a:spcPct val="110000"/>
               </a:lnSpc>
               <a:spcAft>
-                <a:spcPts val="1080"/>
-              </a:spcAft>
-            </a:pPr>
-            <a:r>
-              <a:rPr sz="1800" b="1">
+                <a:spcPts val="450"/>
+              </a:spcAft>
+            </a:pPr>
+            <a:r>
+              <a:rPr sz="1500" b="1">
                 <a:solidFill>
                   <a:srgbClr val="14181F"/>
                 </a:solidFill>
@@ -4585,170 +4614,110 @@
               <a:t>•  </a:t>
             </a:r>
             <a:r>
-              <a:rPr sz="1800" b="1">
-                <a:solidFill>
-                  <a:srgbClr val="14181F"/>
-                </a:solidFill>
-                <a:latin typeface="Arial"/>
-              </a:rPr>
-              <a:t>Context-aware retrieval: </a:t>
-            </a:r>
-            <a:r>
-              <a:rPr sz="1800" b="0">
-                <a:solidFill>
-                  <a:srgbClr val="14181F"/>
-                </a:solidFill>
-                <a:latin typeface="Arial"/>
-              </a:rPr>
-              <a:t>Vertex AI Search over catalog and order history for richer personalization</a:t>
-            </a:r>
-          </a:p>
+              <a:rPr sz="1500" b="0">
+                <a:solidFill>
+                  <a:srgbClr val="14181F"/>
+                </a:solidFill>
+                <a:latin typeface="Arial"/>
+              </a:rPr>
+              <a:t>65 automated tests cover the Baby Trails adapter, segmentation, opt-in and STOP, the guardrail, routing and the approval API.</a:t>
+            </a:r>
+          </a:p>
+        </p:txBody>
+      </p:sp>
+      <p:sp>
+        <p:nvSpPr>
+          <p:cNvPr id="17" name="Rounded Rectangle 16"/>
+          <p:cNvSpPr/>
+          <p:nvPr/>
+        </p:nvSpPr>
+        <p:spPr>
+          <a:xfrm>
+            <a:off x="457200" y="5440680"/>
+            <a:ext cx="11247120" cy="1143000"/>
+          </a:xfrm>
+          <a:prstGeom prst="roundRect">
+            <a:avLst>
+              <a:gd name="adj" fmla="val 6000"/>
+            </a:avLst>
+          </a:prstGeom>
+          <a:solidFill>
+            <a:srgbClr val="FDE8E6"/>
+          </a:solidFill>
+          <a:ln>
+            <a:noFill/>
+          </a:ln>
+          <a:effectLst/>
+        </p:spPr>
+        <p:style>
+          <a:lnRef idx="1">
+            <a:schemeClr val="accent1"/>
+          </a:lnRef>
+          <a:fillRef idx="3">
+            <a:schemeClr val="accent1"/>
+          </a:fillRef>
+          <a:effectRef idx="2">
+            <a:schemeClr val="accent1"/>
+          </a:effectRef>
+          <a:fontRef idx="minor">
+            <a:schemeClr val="lt1"/>
+          </a:fontRef>
+        </p:style>
+        <p:txBody>
+          <a:bodyPr rtlCol="0" anchor="ctr"/>
+          <a:lstStyle/>
+          <a:p>
+            <a:pPr algn="ctr"/>
+          </a:p>
+        </p:txBody>
+      </p:sp>
+      <p:sp>
+        <p:nvSpPr>
+          <p:cNvPr id="18" name="TextBox 17"/>
+          <p:cNvSpPr txBox="1"/>
+          <p:nvPr/>
+        </p:nvSpPr>
+        <p:spPr>
+          <a:xfrm>
+            <a:off x="640080" y="5486400"/>
+            <a:ext cx="10881360" cy="1097280"/>
+          </a:xfrm>
+          <a:prstGeom prst="rect">
+            <a:avLst/>
+          </a:prstGeom>
+          <a:noFill/>
+        </p:spPr>
+        <p:txBody>
+          <a:bodyPr wrap="square" anchor="t" lIns="45720" rIns="45720" tIns="27432" bIns="27432">
+            <a:spAutoFit/>
+          </a:bodyPr>
+          <a:lstStyle/>
           <a:p>
             <a:pPr algn="l">
               <a:lnSpc>
                 <a:spcPct val="110000"/>
               </a:lnSpc>
               <a:spcAft>
-                <a:spcPts val="1080"/>
-              </a:spcAft>
-            </a:pPr>
-            <a:r>
-              <a:rPr sz="1800" b="1">
-                <a:solidFill>
-                  <a:srgbClr val="14181F"/>
-                </a:solidFill>
-                <a:latin typeface="Arial"/>
-              </a:rPr>
-              <a:t>•  </a:t>
-            </a:r>
-            <a:r>
-              <a:rPr sz="1800" b="1">
-                <a:solidFill>
-                  <a:srgbClr val="14181F"/>
-                </a:solidFill>
-                <a:latin typeface="Arial"/>
-              </a:rPr>
-              <a:t>Inventory-aware campaigns: </a:t>
-            </a:r>
-            <a:r>
-              <a:rPr sz="1800" b="0">
-                <a:solidFill>
-                  <a:srgbClr val="14181F"/>
-                </a:solidFill>
-                <a:latin typeface="Arial"/>
-              </a:rPr>
-              <a:t>promote what is in stock, pause what is not</a:t>
-            </a:r>
-          </a:p>
-          <a:p>
-            <a:pPr algn="l">
-              <a:lnSpc>
-                <a:spcPct val="110000"/>
-              </a:lnSpc>
-              <a:spcAft>
-                <a:spcPts val="1080"/>
-              </a:spcAft>
-            </a:pPr>
-            <a:r>
-              <a:rPr sz="1800" b="1">
-                <a:solidFill>
-                  <a:srgbClr val="14181F"/>
-                </a:solidFill>
-                <a:latin typeface="Arial"/>
-              </a:rPr>
-              <a:t>•  </a:t>
-            </a:r>
-            <a:r>
-              <a:rPr sz="1800" b="1">
-                <a:solidFill>
-                  <a:srgbClr val="14181F"/>
-                </a:solidFill>
-                <a:latin typeface="Arial"/>
-              </a:rPr>
-              <a:t>More channels: </a:t>
-            </a:r>
-            <a:r>
-              <a:rPr sz="1800" b="0">
-                <a:solidFill>
-                  <a:srgbClr val="14181F"/>
-                </a:solidFill>
-                <a:latin typeface="Arial"/>
-              </a:rPr>
-              <a:t>SMS and Instagram DMs alongside WhatsApp and email</a:t>
-            </a:r>
-          </a:p>
-          <a:p>
-            <a:pPr algn="l">
-              <a:lnSpc>
-                <a:spcPct val="110000"/>
-              </a:lnSpc>
-              <a:spcAft>
-                <a:spcPts val="1080"/>
-              </a:spcAft>
-            </a:pPr>
-            <a:r>
-              <a:rPr sz="1800" b="1">
-                <a:solidFill>
-                  <a:srgbClr val="14181F"/>
-                </a:solidFill>
-                <a:latin typeface="Arial"/>
-              </a:rPr>
-              <a:t>•  </a:t>
-            </a:r>
-            <a:r>
-              <a:rPr sz="1800" b="1">
-                <a:solidFill>
-                  <a:srgbClr val="14181F"/>
-                </a:solidFill>
-                <a:latin typeface="Arial"/>
-              </a:rPr>
-              <a:t>Predictive intelligence: </a:t>
-            </a:r>
-            <a:r>
-              <a:rPr sz="1800" b="0">
-                <a:solidFill>
-                  <a:srgbClr val="14181F"/>
-                </a:solidFill>
-                <a:latin typeface="Arial"/>
-              </a:rPr>
-              <a:t>churn and lifetime-value scoring with BigQuery ML beyond RFM</a:t>
-            </a:r>
-          </a:p>
-          <a:p>
-            <a:pPr algn="l">
-              <a:lnSpc>
-                <a:spcPct val="110000"/>
-              </a:lnSpc>
-              <a:spcAft>
-                <a:spcPts val="1080"/>
-              </a:spcAft>
-            </a:pPr>
-            <a:r>
-              <a:rPr sz="1800" b="1">
-                <a:solidFill>
-                  <a:srgbClr val="14181F"/>
-                </a:solidFill>
-                <a:latin typeface="Arial"/>
-              </a:rPr>
-              <a:t>•  </a:t>
-            </a:r>
-            <a:r>
-              <a:rPr sz="1800" b="1">
-                <a:solidFill>
-                  <a:srgbClr val="14181F"/>
-                </a:solidFill>
-                <a:latin typeface="Arial"/>
-              </a:rPr>
-              <a:t>Trust-earning autonomy at scale: </a:t>
-            </a:r>
-            <a:r>
-              <a:rPr sz="1800" b="0">
-                <a:solidFill>
-                  <a:srgbClr val="14181F"/>
-                </a:solidFill>
-                <a:latin typeface="Arial"/>
-              </a:rPr>
-              <a:t>merchant edits teach the model; the cockpit becomes an exception-handling tool, not a daily chore</a:t>
+                <a:spcPts val="630"/>
+              </a:spcAft>
+            </a:pPr>
+            <a:r>
+              <a:rPr sz="1400" b="1">
+                <a:solidFill>
+                  <a:srgbClr val="14181F"/>
+                </a:solidFill>
+                <a:latin typeface="Arial"/>
+              </a:rPr>
+              <a:t>Honest scope. </a:t>
+            </a:r>
+            <a:r>
+              <a:rPr sz="1400" b="0">
+                <a:solidFill>
+                  <a:srgbClr val="14181F"/>
+                </a:solidFill>
+                <a:latin typeface="Arial"/>
+              </a:rPr>
+              <a:t>This tests the guardrail with our own corruption set on synthetic data, not Gemini's real output or real customers. Pilot metrics (auto-send rate, approval latency, time saved, recovered revenue) will be measured on Babytrail's data at the Nov 6 prototype evaluation and replace the simulated figures.</a:t>
             </a:r>
           </a:p>
         </p:txBody>
@@ -4832,7 +4801,7 @@
                 </a:solidFill>
                 <a:latin typeface="Arial"/>
               </a:rPr>
-              <a:t>Provide links to your</a:t>
+              <a:t>Additional details / future development</a:t>
             </a:r>
           </a:p>
         </p:txBody>
@@ -4845,8 +4814,8 @@
         </p:nvSpPr>
         <p:spPr>
           <a:xfrm>
-            <a:off x="640080" y="1645920"/>
-            <a:ext cx="10972800" cy="640080"/>
+            <a:off x="548640" y="1463040"/>
+            <a:ext cx="11064240" cy="4937760"/>
           </a:xfrm>
           <a:prstGeom prst="rect">
             <a:avLst/>
@@ -4864,128 +4833,257 @@
                 <a:spcPct val="110000"/>
               </a:lnSpc>
               <a:spcAft>
-                <a:spcPts val="990"/>
-              </a:spcAft>
-            </a:pPr>
-            <a:r>
-              <a:rPr sz="2200" b="1">
-                <a:solidFill>
-                  <a:srgbClr val="14181F"/>
-                </a:solidFill>
-                <a:latin typeface="Arial"/>
-              </a:rPr>
-              <a:t>GitHub Public Repository: </a:t>
-            </a:r>
-            <a:r>
-              <a:rPr sz="2200" b="0">
-                <a:solidFill>
-                  <a:srgbClr val="14181F"/>
-                </a:solidFill>
-                <a:latin typeface="Arial"/>
-              </a:rPr>
-              <a:t>https://github.com/JayMandava/rekindle</a:t>
-            </a:r>
-          </a:p>
-        </p:txBody>
-      </p:sp>
-      <p:sp>
-        <p:nvSpPr>
-          <p:cNvPr id="5" name="TextBox 4"/>
-          <p:cNvSpPr txBox="1"/>
-          <p:nvPr/>
-        </p:nvSpPr>
-        <p:spPr>
-          <a:xfrm>
-            <a:off x="640080" y="2468880"/>
-            <a:ext cx="10972800" cy="640080"/>
-          </a:xfrm>
-          <a:prstGeom prst="rect">
-            <a:avLst/>
-          </a:prstGeom>
-          <a:noFill/>
-        </p:spPr>
-        <p:txBody>
-          <a:bodyPr wrap="square" anchor="t" lIns="45720" rIns="45720" tIns="27432" bIns="27432">
-            <a:spAutoFit/>
-          </a:bodyPr>
-          <a:lstStyle/>
+                <a:spcPts val="1080"/>
+              </a:spcAft>
+            </a:pPr>
+            <a:r>
+              <a:rPr sz="1800" b="1">
+                <a:solidFill>
+                  <a:srgbClr val="14181F"/>
+                </a:solidFill>
+                <a:latin typeface="Arial"/>
+              </a:rPr>
+              <a:t>•  </a:t>
+            </a:r>
+            <a:r>
+              <a:rPr sz="1800" b="1">
+                <a:solidFill>
+                  <a:srgbClr val="14181F"/>
+                </a:solidFill>
+                <a:latin typeface="Arial"/>
+              </a:rPr>
+              <a:t>Second-layer semantic verifier: </a:t>
+            </a:r>
+            <a:r>
+              <a:rPr sz="1800" b="0">
+                <a:solidFill>
+                  <a:srgbClr val="14181F"/>
+                </a:solidFill>
+                <a:latin typeface="Arial"/>
+              </a:rPr>
+              <a:t>a Gemini entailment check on top of the deterministic one, for paraphrased claims no rule can see</a:t>
+            </a:r>
+          </a:p>
           <a:p>
             <a:pPr algn="l">
               <a:lnSpc>
                 <a:spcPct val="110000"/>
               </a:lnSpc>
               <a:spcAft>
-                <a:spcPts val="990"/>
-              </a:spcAft>
-            </a:pPr>
-            <a:r>
-              <a:rPr sz="2200" b="1">
-                <a:solidFill>
-                  <a:srgbClr val="14181F"/>
-                </a:solidFill>
-                <a:latin typeface="Arial"/>
-              </a:rPr>
-              <a:t>Demo Video Link (3 minutes): </a:t>
-            </a:r>
-            <a:r>
-              <a:rPr sz="2200" b="0">
-                <a:solidFill>
-                  <a:srgbClr val="14181F"/>
-                </a:solidFill>
-                <a:latin typeface="Arial"/>
-              </a:rPr>
-              <a:t>[add before submission]</a:t>
-            </a:r>
-          </a:p>
-        </p:txBody>
-      </p:sp>
-      <p:sp>
-        <p:nvSpPr>
-          <p:cNvPr id="6" name="TextBox 5"/>
-          <p:cNvSpPr txBox="1"/>
-          <p:nvPr/>
-        </p:nvSpPr>
-        <p:spPr>
-          <a:xfrm>
-            <a:off x="640080" y="3291840"/>
-            <a:ext cx="10972800" cy="640080"/>
-          </a:xfrm>
-          <a:prstGeom prst="rect">
-            <a:avLst/>
-          </a:prstGeom>
-          <a:noFill/>
-        </p:spPr>
-        <p:txBody>
-          <a:bodyPr wrap="square" anchor="t" lIns="45720" rIns="45720" tIns="27432" bIns="27432">
-            <a:spAutoFit/>
-          </a:bodyPr>
-          <a:lstStyle/>
+                <a:spcPts val="1080"/>
+              </a:spcAft>
+            </a:pPr>
+            <a:r>
+              <a:rPr sz="1800" b="1">
+                <a:solidFill>
+                  <a:srgbClr val="14181F"/>
+                </a:solidFill>
+                <a:latin typeface="Arial"/>
+              </a:rPr>
+              <a:t>•  </a:t>
+            </a:r>
+            <a:r>
+              <a:rPr sz="1800" b="1">
+                <a:solidFill>
+                  <a:srgbClr val="14181F"/>
+                </a:solidFill>
+                <a:latin typeface="Arial"/>
+              </a:rPr>
+              <a:t>Native integrations: </a:t>
+            </a:r>
+            <a:r>
+              <a:rPr sz="1800" b="0">
+                <a:solidFill>
+                  <a:srgbClr val="14181F"/>
+                </a:solidFill>
+                <a:latin typeface="Arial"/>
+              </a:rPr>
+              <a:t>Shopify, WooCommerce and Unicommerce for one-click onboarding</a:t>
+            </a:r>
+          </a:p>
           <a:p>
             <a:pPr algn="l">
               <a:lnSpc>
                 <a:spcPct val="110000"/>
               </a:lnSpc>
               <a:spcAft>
-                <a:spcPts val="990"/>
-              </a:spcAft>
-            </a:pPr>
-            <a:r>
-              <a:rPr sz="2200" b="1">
-                <a:solidFill>
-                  <a:srgbClr val="14181F"/>
-                </a:solidFill>
-                <a:latin typeface="Arial"/>
-              </a:rPr>
-              <a:t>Final Product Link: </a:t>
-            </a:r>
-            <a:r>
-              <a:rPr sz="2200" b="0">
-                <a:solidFill>
-                  <a:srgbClr val="14181F"/>
-                </a:solidFill>
-                <a:latin typeface="Arial"/>
-              </a:rPr>
-              <a:t>[add before submission: Cloud Run URL]</a:t>
+                <a:spcPts val="1080"/>
+              </a:spcAft>
+            </a:pPr>
+            <a:r>
+              <a:rPr sz="1800" b="1">
+                <a:solidFill>
+                  <a:srgbClr val="14181F"/>
+                </a:solidFill>
+                <a:latin typeface="Arial"/>
+              </a:rPr>
+              <a:t>•  </a:t>
+            </a:r>
+            <a:r>
+              <a:rPr sz="1800" b="1">
+                <a:solidFill>
+                  <a:srgbClr val="14181F"/>
+                </a:solidFill>
+                <a:latin typeface="Arial"/>
+              </a:rPr>
+              <a:t>Context-aware retrieval: </a:t>
+            </a:r>
+            <a:r>
+              <a:rPr sz="1800" b="0">
+                <a:solidFill>
+                  <a:srgbClr val="14181F"/>
+                </a:solidFill>
+                <a:latin typeface="Arial"/>
+              </a:rPr>
+              <a:t>Vertex AI Search over catalog and order history for richer personalization</a:t>
+            </a:r>
+          </a:p>
+          <a:p>
+            <a:pPr algn="l">
+              <a:lnSpc>
+                <a:spcPct val="110000"/>
+              </a:lnSpc>
+              <a:spcAft>
+                <a:spcPts val="1080"/>
+              </a:spcAft>
+            </a:pPr>
+            <a:r>
+              <a:rPr sz="1800" b="1">
+                <a:solidFill>
+                  <a:srgbClr val="14181F"/>
+                </a:solidFill>
+                <a:latin typeface="Arial"/>
+              </a:rPr>
+              <a:t>•  </a:t>
+            </a:r>
+            <a:r>
+              <a:rPr sz="1800" b="1">
+                <a:solidFill>
+                  <a:srgbClr val="14181F"/>
+                </a:solidFill>
+                <a:latin typeface="Arial"/>
+              </a:rPr>
+              <a:t>Inventory-aware campaigns: </a:t>
+            </a:r>
+            <a:r>
+              <a:rPr sz="1800" b="0">
+                <a:solidFill>
+                  <a:srgbClr val="14181F"/>
+                </a:solidFill>
+                <a:latin typeface="Arial"/>
+              </a:rPr>
+              <a:t>promote what is in stock, pause what is not</a:t>
+            </a:r>
+          </a:p>
+          <a:p>
+            <a:pPr algn="l">
+              <a:lnSpc>
+                <a:spcPct val="110000"/>
+              </a:lnSpc>
+              <a:spcAft>
+                <a:spcPts val="1080"/>
+              </a:spcAft>
+            </a:pPr>
+            <a:r>
+              <a:rPr sz="1800" b="1">
+                <a:solidFill>
+                  <a:srgbClr val="14181F"/>
+                </a:solidFill>
+                <a:latin typeface="Arial"/>
+              </a:rPr>
+              <a:t>•  </a:t>
+            </a:r>
+            <a:r>
+              <a:rPr sz="1800" b="1">
+                <a:solidFill>
+                  <a:srgbClr val="14181F"/>
+                </a:solidFill>
+                <a:latin typeface="Arial"/>
+              </a:rPr>
+              <a:t>More channels: </a:t>
+            </a:r>
+            <a:r>
+              <a:rPr sz="1800" b="0">
+                <a:solidFill>
+                  <a:srgbClr val="14181F"/>
+                </a:solidFill>
+                <a:latin typeface="Arial"/>
+              </a:rPr>
+              <a:t>SMS and Instagram DMs alongside WhatsApp and email</a:t>
+            </a:r>
+          </a:p>
+          <a:p>
+            <a:pPr algn="l">
+              <a:lnSpc>
+                <a:spcPct val="110000"/>
+              </a:lnSpc>
+              <a:spcAft>
+                <a:spcPts val="1080"/>
+              </a:spcAft>
+            </a:pPr>
+            <a:r>
+              <a:rPr sz="1800" b="1">
+                <a:solidFill>
+                  <a:srgbClr val="14181F"/>
+                </a:solidFill>
+                <a:latin typeface="Arial"/>
+              </a:rPr>
+              <a:t>•  </a:t>
+            </a:r>
+            <a:r>
+              <a:rPr sz="1800" b="1">
+                <a:solidFill>
+                  <a:srgbClr val="14181F"/>
+                </a:solidFill>
+                <a:latin typeface="Arial"/>
+              </a:rPr>
+              <a:t>Predictive intelligence: </a:t>
+            </a:r>
+            <a:r>
+              <a:rPr sz="1800" b="0">
+                <a:solidFill>
+                  <a:srgbClr val="14181F"/>
+                </a:solidFill>
+                <a:latin typeface="Arial"/>
+              </a:rPr>
+              <a:t>churn and lifetime-value scoring with BigQuery ML beyond RFM</a:t>
+            </a:r>
+          </a:p>
+          <a:p>
+            <a:pPr algn="l">
+              <a:lnSpc>
+                <a:spcPct val="110000"/>
+              </a:lnSpc>
+              <a:spcAft>
+                <a:spcPts val="1080"/>
+              </a:spcAft>
+            </a:pPr>
+            <a:r>
+              <a:rPr sz="1800" b="1">
+                <a:solidFill>
+                  <a:srgbClr val="14181F"/>
+                </a:solidFill>
+                <a:latin typeface="Arial"/>
+              </a:rPr>
+              <a:t>•  </a:t>
+            </a:r>
+            <a:r>
+              <a:rPr sz="1800" b="1">
+                <a:solidFill>
+                  <a:srgbClr val="14181F"/>
+                </a:solidFill>
+                <a:latin typeface="Arial"/>
+              </a:rPr>
+              <a:t>Trust-earning autonomy at scale: </a:t>
+            </a:r>
+            <a:r>
+              <a:rPr sz="1800" b="0">
+                <a:solidFill>
+                  <a:srgbClr val="14181F"/>
+                </a:solidFill>
+                <a:latin typeface="Arial"/>
+              </a:rPr>
+              <a:t>merchant edits teach the model; the cockpit becomes an exception-handling tool, not a daily chore</a:t>
             </a:r>
           </a:p>
         </p:txBody>
@@ -5069,6 +5167,243 @@
                 </a:solidFill>
                 <a:latin typeface="Arial"/>
               </a:rPr>
+              <a:t>Provide links to your</a:t>
+            </a:r>
+          </a:p>
+        </p:txBody>
+      </p:sp>
+      <p:sp>
+        <p:nvSpPr>
+          <p:cNvPr id="4" name="TextBox 3"/>
+          <p:cNvSpPr txBox="1"/>
+          <p:nvPr/>
+        </p:nvSpPr>
+        <p:spPr>
+          <a:xfrm>
+            <a:off x="640080" y="1645920"/>
+            <a:ext cx="10972800" cy="640080"/>
+          </a:xfrm>
+          <a:prstGeom prst="rect">
+            <a:avLst/>
+          </a:prstGeom>
+          <a:noFill/>
+        </p:spPr>
+        <p:txBody>
+          <a:bodyPr wrap="square" anchor="t" lIns="45720" rIns="45720" tIns="27432" bIns="27432">
+            <a:spAutoFit/>
+          </a:bodyPr>
+          <a:lstStyle/>
+          <a:p>
+            <a:pPr algn="l">
+              <a:lnSpc>
+                <a:spcPct val="110000"/>
+              </a:lnSpc>
+              <a:spcAft>
+                <a:spcPts val="990"/>
+              </a:spcAft>
+            </a:pPr>
+            <a:r>
+              <a:rPr sz="2200" b="1">
+                <a:solidFill>
+                  <a:srgbClr val="14181F"/>
+                </a:solidFill>
+                <a:latin typeface="Arial"/>
+              </a:rPr>
+              <a:t>GitHub Public Repository: </a:t>
+            </a:r>
+            <a:r>
+              <a:rPr sz="2200" b="0">
+                <a:solidFill>
+                  <a:srgbClr val="14181F"/>
+                </a:solidFill>
+                <a:latin typeface="Arial"/>
+              </a:rPr>
+              <a:t>https://github.com/JayMandava/rekindle</a:t>
+            </a:r>
+          </a:p>
+        </p:txBody>
+      </p:sp>
+      <p:sp>
+        <p:nvSpPr>
+          <p:cNvPr id="5" name="TextBox 4"/>
+          <p:cNvSpPr txBox="1"/>
+          <p:nvPr/>
+        </p:nvSpPr>
+        <p:spPr>
+          <a:xfrm>
+            <a:off x="640080" y="2468880"/>
+            <a:ext cx="10972800" cy="640080"/>
+          </a:xfrm>
+          <a:prstGeom prst="rect">
+            <a:avLst/>
+          </a:prstGeom>
+          <a:noFill/>
+        </p:spPr>
+        <p:txBody>
+          <a:bodyPr wrap="square" anchor="t" lIns="45720" rIns="45720" tIns="27432" bIns="27432">
+            <a:spAutoFit/>
+          </a:bodyPr>
+          <a:lstStyle/>
+          <a:p>
+            <a:pPr algn="l">
+              <a:lnSpc>
+                <a:spcPct val="110000"/>
+              </a:lnSpc>
+              <a:spcAft>
+                <a:spcPts val="990"/>
+              </a:spcAft>
+            </a:pPr>
+            <a:r>
+              <a:rPr sz="2200" b="1">
+                <a:solidFill>
+                  <a:srgbClr val="14181F"/>
+                </a:solidFill>
+                <a:latin typeface="Arial"/>
+              </a:rPr>
+              <a:t>Demo Video Link (3 minutes): </a:t>
+            </a:r>
+            <a:r>
+              <a:rPr sz="2200" b="0">
+                <a:solidFill>
+                  <a:srgbClr val="14181F"/>
+                </a:solidFill>
+                <a:latin typeface="Arial"/>
+              </a:rPr>
+              <a:t>[add before submission]</a:t>
+            </a:r>
+          </a:p>
+        </p:txBody>
+      </p:sp>
+      <p:sp>
+        <p:nvSpPr>
+          <p:cNvPr id="6" name="TextBox 5"/>
+          <p:cNvSpPr txBox="1"/>
+          <p:nvPr/>
+        </p:nvSpPr>
+        <p:spPr>
+          <a:xfrm>
+            <a:off x="640080" y="3291840"/>
+            <a:ext cx="10972800" cy="640080"/>
+          </a:xfrm>
+          <a:prstGeom prst="rect">
+            <a:avLst/>
+          </a:prstGeom>
+          <a:noFill/>
+        </p:spPr>
+        <p:txBody>
+          <a:bodyPr wrap="square" anchor="t" lIns="45720" rIns="45720" tIns="27432" bIns="27432">
+            <a:spAutoFit/>
+          </a:bodyPr>
+          <a:lstStyle/>
+          <a:p>
+            <a:pPr algn="l">
+              <a:lnSpc>
+                <a:spcPct val="110000"/>
+              </a:lnSpc>
+              <a:spcAft>
+                <a:spcPts val="990"/>
+              </a:spcAft>
+            </a:pPr>
+            <a:r>
+              <a:rPr sz="2200" b="1">
+                <a:solidFill>
+                  <a:srgbClr val="14181F"/>
+                </a:solidFill>
+                <a:latin typeface="Arial"/>
+              </a:rPr>
+              <a:t>Final Product Link: </a:t>
+            </a:r>
+            <a:r>
+              <a:rPr sz="2200" b="0">
+                <a:solidFill>
+                  <a:srgbClr val="14181F"/>
+                </a:solidFill>
+                <a:latin typeface="Arial"/>
+              </a:rPr>
+              <a:t>[add before submission: Cloud Run URL]</a:t>
+            </a:r>
+          </a:p>
+        </p:txBody>
+      </p:sp>
+    </p:spTree>
+  </p:cSld>
+  <p:clrMapOvr>
+    <a:masterClrMapping/>
+  </p:clrMapOvr>
+</p:sld>
+</file>
+
+<file path=ppt/slides/slide15.xml><?xml version="1.0" encoding="utf-8"?>
+<p:sld xmlns:a="http://schemas.openxmlformats.org/drawingml/2006/main" xmlns:p="http://schemas.openxmlformats.org/presentationml/2006/main" xmlns:r="http://schemas.openxmlformats.org/officeDocument/2006/relationships">
+  <p:cSld>
+    <p:spTree>
+      <p:nvGrpSpPr>
+        <p:cNvPr id="1" name=""/>
+        <p:cNvGrpSpPr/>
+        <p:nvPr/>
+      </p:nvGrpSpPr>
+      <p:grpSpPr/>
+      <p:pic>
+        <p:nvPicPr>
+          <p:cNvPr id="2" name="Picture 1" descr="header.png"/>
+          <p:cNvPicPr>
+            <a:picLocks noChangeAspect="1"/>
+          </p:cNvPicPr>
+          <p:nvPr/>
+        </p:nvPicPr>
+        <p:blipFill>
+          <a:blip r:embed="rId2"/>
+          <a:stretch>
+            <a:fillRect/>
+          </a:stretch>
+        </p:blipFill>
+        <p:spPr>
+          <a:xfrm>
+            <a:off x="0" y="0"/>
+            <a:ext cx="12191695" cy="676639"/>
+          </a:xfrm>
+          <a:prstGeom prst="rect">
+            <a:avLst/>
+          </a:prstGeom>
+        </p:spPr>
+      </p:pic>
+      <p:sp>
+        <p:nvSpPr>
+          <p:cNvPr id="3" name="TextBox 2"/>
+          <p:cNvSpPr txBox="1"/>
+          <p:nvPr/>
+        </p:nvSpPr>
+        <p:spPr>
+          <a:xfrm>
+            <a:off x="457200" y="749808"/>
+            <a:ext cx="11247120" cy="548640"/>
+          </a:xfrm>
+          <a:prstGeom prst="rect">
+            <a:avLst/>
+          </a:prstGeom>
+          <a:noFill/>
+        </p:spPr>
+        <p:txBody>
+          <a:bodyPr wrap="square" anchor="t" lIns="45720" rIns="45720" tIns="27432" bIns="27432">
+            <a:spAutoFit/>
+          </a:bodyPr>
+          <a:lstStyle/>
+          <a:p>
+            <a:pPr algn="l">
+              <a:lnSpc>
+                <a:spcPct val="110000"/>
+              </a:lnSpc>
+              <a:spcAft>
+                <a:spcPts val="1260"/>
+              </a:spcAft>
+            </a:pPr>
+            <a:r>
+              <a:rPr sz="2800" b="1">
+                <a:solidFill>
+                  <a:srgbClr val="14181F"/>
+                </a:solidFill>
+                <a:latin typeface="Arial"/>
+              </a:rPr>
               <a:t>Team</a:t>
             </a:r>
           </a:p>
@@ -5632,7 +5967,7 @@
 </p:sld>
 </file>
 
-<file path=ppt/slides/slide15.xml><?xml version="1.0" encoding="utf-8"?>
+<file path=ppt/slides/slide16.xml><?xml version="1.0" encoding="utf-8"?>
 <p:sld xmlns:a="http://schemas.openxmlformats.org/drawingml/2006/main" xmlns:p="http://schemas.openxmlformats.org/presentationml/2006/main" xmlns:r="http://schemas.openxmlformats.org/officeDocument/2006/relationships">
   <p:cSld>
     <p:spTree>
@@ -5796,7 +6131,7 @@
                 </a:solidFill>
                 <a:latin typeface="Arial"/>
               </a:rPr>
-              <a:t>It finds customers who have gone quiet, writes a personal WhatsApp or email message for each, and sends only what has been fact-checked. Human-supervised first; autonomy is earned.</a:t>
+              <a:t>It finds customers who have gone quiet, writes a personal WhatsApp message for each (email optional), and sends only what has been fact-checked. Human-supervised first; autonomy is earned.</a:t>
             </a:r>
           </a:p>
         </p:txBody>
@@ -5809,8 +6144,8 @@
         </p:nvSpPr>
         <p:spPr>
           <a:xfrm>
-            <a:off x="457200" y="2880360"/>
-            <a:ext cx="2651760" cy="2651760"/>
+            <a:off x="457200" y="2834640"/>
+            <a:ext cx="2651760" cy="2788920"/>
           </a:xfrm>
           <a:prstGeom prst="roundRect">
             <a:avLst>
@@ -5926,7 +6261,7 @@
                 </a:solidFill>
                 <a:latin typeface="Arial"/>
               </a:rPr>
-              <a:t>BigQuery SQL scores recency, frequency and spend, and spots milestones (a child turning one). Deterministic, auditable, no LLM.</a:t>
+              <a:t>BigQuery SQL scores recency, frequency and spend from Baby Trails bookings and spots the next natural session, like a newborn reaching baby-session age. No LLM.</a:t>
             </a:r>
           </a:p>
         </p:txBody>
@@ -5939,8 +6274,8 @@
         </p:nvSpPr>
         <p:spPr>
           <a:xfrm>
-            <a:off x="3291840" y="2880360"/>
-            <a:ext cx="2651760" cy="2651760"/>
+            <a:off x="3291840" y="2834640"/>
+            <a:ext cx="2651760" cy="2788920"/>
           </a:xfrm>
           <a:prstGeom prst="roundRect">
             <a:avLst>
@@ -6056,7 +6391,7 @@
                 </a:solidFill>
                 <a:latin typeface="Arial"/>
               </a:rPr>
-              <a:t>Gemini on Vertex AI drafts in the customer's language. Every claim must cite a fact from that customer's own record.</a:t>
+              <a:t>Gemini on Vertex AI drafts the message. Every claim must cite a fact from that customer's own record. It never invents a name, price or memory.</a:t>
             </a:r>
           </a:p>
         </p:txBody>
@@ -6069,8 +6404,8 @@
         </p:nvSpPr>
         <p:spPr>
           <a:xfrm>
-            <a:off x="6126480" y="2880360"/>
-            <a:ext cx="2651760" cy="2651760"/>
+            <a:off x="6126480" y="2834640"/>
+            <a:ext cx="2651760" cy="2788920"/>
           </a:xfrm>
           <a:prstGeom prst="roundRect">
             <a:avLst>
@@ -6186,7 +6521,7 @@
                 </a:solidFill>
                 <a:latin typeface="Arial"/>
               </a:rPr>
-              <a:t>A deterministic guardrail blocks invented numbers, names, offers and memories. Consent and STOP are enforced before any generation.</a:t>
+              <a:t>A deterministic guardrail blocks anything ungrounded. Only customers who opted in are ever drafted for, and STOP is honoured before any generation.</a:t>
             </a:r>
           </a:p>
         </p:txBody>
@@ -6199,8 +6534,8 @@
         </p:nvSpPr>
         <p:spPr>
           <a:xfrm>
-            <a:off x="8961120" y="2880360"/>
-            <a:ext cx="2651760" cy="2651760"/>
+            <a:off x="8961120" y="2834640"/>
+            <a:ext cx="2651760" cy="2788920"/>
           </a:xfrm>
           <a:prstGeom prst="roundRect">
             <a:avLst>
@@ -6358,7 +6693,7 @@
                 </a:solidFill>
                 <a:latin typeface="Arial"/>
               </a:rPr>
-              <a:t>Built entirely on Google Cloud: BigQuery, Gemini on Vertex AI, Cloud Run, Firestore, Looker Studio. Pilot partner: Babytrail Photography. A studio is the hardest test of personalization because every message touches a family milestone; the same engine generalizes to apparel, D2C, salons and clinics.</a:t>
+              <a:t>Built on Google Cloud: BigQuery, Gemini on Vertex AI, Cloud Run, Firestore, Looker Studio. Pilot partner: Babytrail Photography (Baby Trails), whose booking system already runs on GCP. A studio is the hardest test of personalization because every message touches a family milestone; the same engine generalizes to apparel, D2C, salons and clinics.</a:t>
             </a:r>
           </a:p>
         </p:txBody>
@@ -6838,7 +7173,7 @@
                 </a:solidFill>
                 <a:latin typeface="Arial"/>
               </a:rPr>
-              <a:t>AI speed without the hallucination risk that keeps merchants from letting AI near their customers. In our adversarial test, 2,783 corrupted drafts were all stopped before sending, and 0 reached a customer without a human.</a:t>
+              <a:t>AI speed without the hallucination risk that keeps merchants from letting AI near their customers. In our adversarial test, 1,864 corrupted drafts were all stopped before sending, and 0 reached a customer without a human.</a:t>
             </a:r>
           </a:p>
         </p:txBody>
@@ -7052,7 +7387,7 @@
                 </a:solidFill>
                 <a:latin typeface="Arial"/>
               </a:rPr>
-              <a:t>RFM scoring and dormancy triggers in one BigQuery query; milestone detection (6/12/18/24 months)</a:t>
+              <a:t>RFM scoring and dormancy triggers in one BigQuery query; journey triggers from the baby's estimated age</a:t>
             </a:r>
           </a:p>
         </p:txBody>
@@ -7660,7 +7995,7 @@
                 </a:solidFill>
                 <a:latin typeface="Arial"/>
               </a:rPr>
-              <a:t>Consent first</a:t>
+              <a:t>Opt-in first</a:t>
             </a:r>
           </a:p>
         </p:txBody>
@@ -7702,7 +8037,7 @@
                 </a:solidFill>
                 <a:latin typeface="Arial"/>
               </a:rPr>
-              <a:t>No consented channel, no draft. STOP in any language suppresses before generation and cancels queued drafts</a:t>
+              <a:t>No opt-in, no draft: the photo-use flag is never treated as messaging consent. STOP suppresses before generation and cancels queued drafts</a:t>
             </a:r>
           </a:p>
         </p:txBody>
@@ -7790,7 +8125,7 @@
                 </a:solidFill>
                 <a:latin typeface="Arial"/>
               </a:rPr>
-              <a:t>WhatsApp + email</a:t>
+              <a:t>WhatsApp-first delivery</a:t>
             </a:r>
           </a:p>
         </p:txBody>
@@ -7832,7 +8167,7 @@
                 </a:solidFill>
                 <a:latin typeface="Arial"/>
               </a:rPr>
-              <a:t>WhatsApp approved-template compliance; Gmail API for email; opt-out line added by the system</a:t>
+              <a:t>Approved Marketing template for dormant customers (24h rule); email optional; opt-out line added by the system</a:t>
             </a:r>
           </a:p>
         </p:txBody>
@@ -8625,6 +8960,773 @@
                 </a:solidFill>
                 <a:latin typeface="Arial"/>
               </a:rPr>
+              <a:t>Built on a real studio: the Baby Trails integration</a:t>
+            </a:r>
+          </a:p>
+        </p:txBody>
+      </p:sp>
+      <p:sp>
+        <p:nvSpPr>
+          <p:cNvPr id="4" name="Rounded Rectangle 3"/>
+          <p:cNvSpPr/>
+          <p:nvPr/>
+        </p:nvSpPr>
+        <p:spPr>
+          <a:xfrm>
+            <a:off x="457200" y="1463040"/>
+            <a:ext cx="3657600" cy="4297680"/>
+          </a:xfrm>
+          <a:prstGeom prst="roundRect">
+            <a:avLst>
+              <a:gd name="adj" fmla="val 6000"/>
+            </a:avLst>
+          </a:prstGeom>
+          <a:solidFill>
+            <a:srgbClr val="E6F4EA"/>
+          </a:solidFill>
+          <a:ln>
+            <a:noFill/>
+          </a:ln>
+          <a:effectLst/>
+        </p:spPr>
+        <p:style>
+          <a:lnRef idx="1">
+            <a:schemeClr val="accent1"/>
+          </a:lnRef>
+          <a:fillRef idx="3">
+            <a:schemeClr val="accent1"/>
+          </a:fillRef>
+          <a:effectRef idx="2">
+            <a:schemeClr val="accent1"/>
+          </a:effectRef>
+          <a:fontRef idx="minor">
+            <a:schemeClr val="lt1"/>
+          </a:fontRef>
+        </p:style>
+        <p:txBody>
+          <a:bodyPr rtlCol="0" anchor="ctr"/>
+          <a:lstStyle/>
+          <a:p>
+            <a:pPr algn="ctr"/>
+          </a:p>
+        </p:txBody>
+      </p:sp>
+      <p:sp>
+        <p:nvSpPr>
+          <p:cNvPr id="5" name="TextBox 4"/>
+          <p:cNvSpPr txBox="1"/>
+          <p:nvPr/>
+        </p:nvSpPr>
+        <p:spPr>
+          <a:xfrm>
+            <a:off x="594360" y="1554480"/>
+            <a:ext cx="3383280" cy="457200"/>
+          </a:xfrm>
+          <a:prstGeom prst="rect">
+            <a:avLst/>
+          </a:prstGeom>
+          <a:noFill/>
+        </p:spPr>
+        <p:txBody>
+          <a:bodyPr wrap="square" anchor="t" lIns="45720" rIns="45720" tIns="27432" bIns="27432">
+            <a:spAutoFit/>
+          </a:bodyPr>
+          <a:lstStyle/>
+          <a:p>
+            <a:pPr algn="l">
+              <a:lnSpc>
+                <a:spcPct val="110000"/>
+              </a:lnSpc>
+              <a:spcAft>
+                <a:spcPts val="900"/>
+              </a:spcAft>
+            </a:pPr>
+            <a:r>
+              <a:rPr sz="2000" b="1">
+                <a:solidFill>
+                  <a:srgbClr val="14181F"/>
+                </a:solidFill>
+                <a:latin typeface="Arial"/>
+              </a:rPr>
+              <a:t>What we read</a:t>
+            </a:r>
+          </a:p>
+        </p:txBody>
+      </p:sp>
+      <p:sp>
+        <p:nvSpPr>
+          <p:cNvPr id="6" name="TextBox 5"/>
+          <p:cNvSpPr txBox="1"/>
+          <p:nvPr/>
+        </p:nvSpPr>
+        <p:spPr>
+          <a:xfrm>
+            <a:off x="594360" y="2103120"/>
+            <a:ext cx="3383280" cy="3566160"/>
+          </a:xfrm>
+          <a:prstGeom prst="rect">
+            <a:avLst/>
+          </a:prstGeom>
+          <a:noFill/>
+        </p:spPr>
+        <p:txBody>
+          <a:bodyPr wrap="square" anchor="t" lIns="45720" rIns="45720" tIns="27432" bIns="27432">
+            <a:spAutoFit/>
+          </a:bodyPr>
+          <a:lstStyle/>
+          <a:p>
+            <a:pPr algn="l">
+              <a:lnSpc>
+                <a:spcPct val="110000"/>
+              </a:lnSpc>
+              <a:spcAft>
+                <a:spcPts val="880"/>
+              </a:spcAft>
+            </a:pPr>
+            <a:r>
+              <a:rPr sz="1600" b="1">
+                <a:solidFill>
+                  <a:srgbClr val="14181F"/>
+                </a:solidFill>
+                <a:latin typeface="Arial"/>
+              </a:rPr>
+              <a:t>•  </a:t>
+            </a:r>
+            <a:r>
+              <a:rPr sz="1600" b="0">
+                <a:solidFill>
+                  <a:srgbClr val="14181F"/>
+                </a:solidFill>
+                <a:latin typeface="Arial"/>
+              </a:rPr>
+              <a:t>Baby Trails' Airtable Bookings: phone, shoot type, baby age, package, totals, paid flags</a:t>
+            </a:r>
+          </a:p>
+          <a:p>
+            <a:pPr algn="l">
+              <a:lnSpc>
+                <a:spcPct val="110000"/>
+              </a:lnSpc>
+              <a:spcAft>
+                <a:spcPts val="880"/>
+              </a:spcAft>
+            </a:pPr>
+            <a:r>
+              <a:rPr sz="1600" b="1">
+                <a:solidFill>
+                  <a:srgbClr val="14181F"/>
+                </a:solidFill>
+                <a:latin typeface="Arial"/>
+              </a:rPr>
+              <a:t>•  </a:t>
+            </a:r>
+            <a:r>
+              <a:rPr sz="1600" b="0">
+                <a:solidFill>
+                  <a:srgbClr val="14181F"/>
+                </a:solidFill>
+                <a:latin typeface="Arial"/>
+              </a:rPr>
+              <a:t>Its catalog: newborn 5-30 days, baby 3-12 months, maternity</a:t>
+            </a:r>
+          </a:p>
+          <a:p>
+            <a:pPr algn="l">
+              <a:lnSpc>
+                <a:spcPct val="110000"/>
+              </a:lnSpc>
+              <a:spcAft>
+                <a:spcPts val="880"/>
+              </a:spcAft>
+            </a:pPr>
+            <a:r>
+              <a:rPr sz="1600" b="1">
+                <a:solidFill>
+                  <a:srgbClr val="14181F"/>
+                </a:solidFill>
+                <a:latin typeface="Arial"/>
+              </a:rPr>
+              <a:t>•  </a:t>
+            </a:r>
+            <a:r>
+              <a:rPr sz="1600" b="0">
+                <a:solidFill>
+                  <a:srgbClr val="14181F"/>
+                </a:solidFill>
+                <a:latin typeface="Arial"/>
+              </a:rPr>
+              <a:t>Same WhatsApp number and GCP project; ReKindle runs beside it</a:t>
+            </a:r>
+          </a:p>
+        </p:txBody>
+      </p:sp>
+      <p:sp>
+        <p:nvSpPr>
+          <p:cNvPr id="7" name="Rounded Rectangle 6"/>
+          <p:cNvSpPr/>
+          <p:nvPr/>
+        </p:nvSpPr>
+        <p:spPr>
+          <a:xfrm>
+            <a:off x="4297680" y="1463040"/>
+            <a:ext cx="3657600" cy="4297680"/>
+          </a:xfrm>
+          <a:prstGeom prst="roundRect">
+            <a:avLst>
+              <a:gd name="adj" fmla="val 6000"/>
+            </a:avLst>
+          </a:prstGeom>
+          <a:solidFill>
+            <a:srgbClr val="FDE8E6"/>
+          </a:solidFill>
+          <a:ln>
+            <a:noFill/>
+          </a:ln>
+          <a:effectLst/>
+        </p:spPr>
+        <p:style>
+          <a:lnRef idx="1">
+            <a:schemeClr val="accent1"/>
+          </a:lnRef>
+          <a:fillRef idx="3">
+            <a:schemeClr val="accent1"/>
+          </a:fillRef>
+          <a:effectRef idx="2">
+            <a:schemeClr val="accent1"/>
+          </a:effectRef>
+          <a:fontRef idx="minor">
+            <a:schemeClr val="lt1"/>
+          </a:fontRef>
+        </p:style>
+        <p:txBody>
+          <a:bodyPr rtlCol="0" anchor="ctr"/>
+          <a:lstStyle/>
+          <a:p>
+            <a:pPr algn="ctr"/>
+          </a:p>
+        </p:txBody>
+      </p:sp>
+      <p:sp>
+        <p:nvSpPr>
+          <p:cNvPr id="8" name="TextBox 7"/>
+          <p:cNvSpPr txBox="1"/>
+          <p:nvPr/>
+        </p:nvSpPr>
+        <p:spPr>
+          <a:xfrm>
+            <a:off x="4434840" y="1554480"/>
+            <a:ext cx="3383280" cy="457200"/>
+          </a:xfrm>
+          <a:prstGeom prst="rect">
+            <a:avLst/>
+          </a:prstGeom>
+          <a:noFill/>
+        </p:spPr>
+        <p:txBody>
+          <a:bodyPr wrap="square" anchor="t" lIns="45720" rIns="45720" tIns="27432" bIns="27432">
+            <a:spAutoFit/>
+          </a:bodyPr>
+          <a:lstStyle/>
+          <a:p>
+            <a:pPr algn="l">
+              <a:lnSpc>
+                <a:spcPct val="110000"/>
+              </a:lnSpc>
+              <a:spcAft>
+                <a:spcPts val="900"/>
+              </a:spcAft>
+            </a:pPr>
+            <a:r>
+              <a:rPr sz="2000" b="1">
+                <a:solidFill>
+                  <a:srgbClr val="14181F"/>
+                </a:solidFill>
+                <a:latin typeface="Arial"/>
+              </a:rPr>
+              <a:t>What we never assume</a:t>
+            </a:r>
+          </a:p>
+        </p:txBody>
+      </p:sp>
+      <p:sp>
+        <p:nvSpPr>
+          <p:cNvPr id="9" name="TextBox 8"/>
+          <p:cNvSpPr txBox="1"/>
+          <p:nvPr/>
+        </p:nvSpPr>
+        <p:spPr>
+          <a:xfrm>
+            <a:off x="4434840" y="2103120"/>
+            <a:ext cx="3383280" cy="3566160"/>
+          </a:xfrm>
+          <a:prstGeom prst="rect">
+            <a:avLst/>
+          </a:prstGeom>
+          <a:noFill/>
+        </p:spPr>
+        <p:txBody>
+          <a:bodyPr wrap="square" anchor="t" lIns="45720" rIns="45720" tIns="27432" bIns="27432">
+            <a:spAutoFit/>
+          </a:bodyPr>
+          <a:lstStyle/>
+          <a:p>
+            <a:pPr algn="l">
+              <a:lnSpc>
+                <a:spcPct val="110000"/>
+              </a:lnSpc>
+              <a:spcAft>
+                <a:spcPts val="880"/>
+              </a:spcAft>
+            </a:pPr>
+            <a:r>
+              <a:rPr sz="1600" b="1">
+                <a:solidFill>
+                  <a:srgbClr val="14181F"/>
+                </a:solidFill>
+                <a:latin typeface="Arial"/>
+              </a:rPr>
+              <a:t>•  </a:t>
+            </a:r>
+            <a:r>
+              <a:rPr sz="1600" b="0">
+                <a:solidFill>
+                  <a:srgbClr val="14181F"/>
+                </a:solidFill>
+                <a:latin typeface="Arial"/>
+              </a:rPr>
+              <a:t>Its photo-use flag is not messaging consent</a:t>
+            </a:r>
+          </a:p>
+          <a:p>
+            <a:pPr algn="l">
+              <a:lnSpc>
+                <a:spcPct val="110000"/>
+              </a:lnSpc>
+              <a:spcAft>
+                <a:spcPts val="880"/>
+              </a:spcAft>
+            </a:pPr>
+            <a:r>
+              <a:rPr sz="1600" b="1">
+                <a:solidFill>
+                  <a:srgbClr val="14181F"/>
+                </a:solidFill>
+                <a:latin typeface="Arial"/>
+              </a:rPr>
+              <a:t>•  </a:t>
+            </a:r>
+            <a:r>
+              <a:rPr sz="1600" b="0">
+                <a:solidFill>
+                  <a:srgbClr val="14181F"/>
+                </a:solidFill>
+                <a:latin typeface="Arial"/>
+              </a:rPr>
+              <a:t>No child name on file, so drafts say 'your little one'</a:t>
+            </a:r>
+          </a:p>
+          <a:p>
+            <a:pPr algn="l">
+              <a:lnSpc>
+                <a:spcPct val="110000"/>
+              </a:lnSpc>
+              <a:spcAft>
+                <a:spcPts val="880"/>
+              </a:spcAft>
+            </a:pPr>
+            <a:r>
+              <a:rPr sz="1600" b="1">
+                <a:solidFill>
+                  <a:srgbClr val="14181F"/>
+                </a:solidFill>
+                <a:latin typeface="Arial"/>
+              </a:rPr>
+              <a:t>•  </a:t>
+            </a:r>
+            <a:r>
+              <a:rPr sz="1600" b="0">
+                <a:solidFill>
+                  <a:srgbClr val="14181F"/>
+                </a:solidFill>
+                <a:latin typeface="Arial"/>
+              </a:rPr>
+              <a:t>Only an age at booking, so milestones are estimates, quoted by month</a:t>
+            </a:r>
+          </a:p>
+          <a:p>
+            <a:pPr algn="l">
+              <a:lnSpc>
+                <a:spcPct val="110000"/>
+              </a:lnSpc>
+              <a:spcAft>
+                <a:spcPts val="880"/>
+              </a:spcAft>
+            </a:pPr>
+            <a:r>
+              <a:rPr sz="1600" b="1">
+                <a:solidFill>
+                  <a:srgbClr val="14181F"/>
+                </a:solidFill>
+                <a:latin typeface="Arial"/>
+              </a:rPr>
+              <a:t>•  </a:t>
+            </a:r>
+            <a:r>
+              <a:rPr sz="1600" b="0">
+                <a:solidFill>
+                  <a:srgbClr val="14181F"/>
+                </a:solidFill>
+                <a:latin typeface="Arial"/>
+              </a:rPr>
+              <a:t>Maternity history never produces a baby message</a:t>
+            </a:r>
+          </a:p>
+        </p:txBody>
+      </p:sp>
+      <p:sp>
+        <p:nvSpPr>
+          <p:cNvPr id="10" name="Rounded Rectangle 9"/>
+          <p:cNvSpPr/>
+          <p:nvPr/>
+        </p:nvSpPr>
+        <p:spPr>
+          <a:xfrm>
+            <a:off x="8138160" y="1463040"/>
+            <a:ext cx="3657600" cy="4297680"/>
+          </a:xfrm>
+          <a:prstGeom prst="roundRect">
+            <a:avLst>
+              <a:gd name="adj" fmla="val 6000"/>
+            </a:avLst>
+          </a:prstGeom>
+          <a:solidFill>
+            <a:srgbClr val="E7EFFB"/>
+          </a:solidFill>
+          <a:ln>
+            <a:noFill/>
+          </a:ln>
+          <a:effectLst/>
+        </p:spPr>
+        <p:style>
+          <a:lnRef idx="1">
+            <a:schemeClr val="accent1"/>
+          </a:lnRef>
+          <a:fillRef idx="3">
+            <a:schemeClr val="accent1"/>
+          </a:fillRef>
+          <a:effectRef idx="2">
+            <a:schemeClr val="accent1"/>
+          </a:effectRef>
+          <a:fontRef idx="minor">
+            <a:schemeClr val="lt1"/>
+          </a:fontRef>
+        </p:style>
+        <p:txBody>
+          <a:bodyPr rtlCol="0" anchor="ctr"/>
+          <a:lstStyle/>
+          <a:p>
+            <a:pPr algn="ctr"/>
+          </a:p>
+        </p:txBody>
+      </p:sp>
+      <p:sp>
+        <p:nvSpPr>
+          <p:cNvPr id="11" name="TextBox 10"/>
+          <p:cNvSpPr txBox="1"/>
+          <p:nvPr/>
+        </p:nvSpPr>
+        <p:spPr>
+          <a:xfrm>
+            <a:off x="8275320" y="1554480"/>
+            <a:ext cx="3383280" cy="457200"/>
+          </a:xfrm>
+          <a:prstGeom prst="rect">
+            <a:avLst/>
+          </a:prstGeom>
+          <a:noFill/>
+        </p:spPr>
+        <p:txBody>
+          <a:bodyPr wrap="square" anchor="t" lIns="45720" rIns="45720" tIns="27432" bIns="27432">
+            <a:spAutoFit/>
+          </a:bodyPr>
+          <a:lstStyle/>
+          <a:p>
+            <a:pPr algn="l">
+              <a:lnSpc>
+                <a:spcPct val="110000"/>
+              </a:lnSpc>
+              <a:spcAft>
+                <a:spcPts val="900"/>
+              </a:spcAft>
+            </a:pPr>
+            <a:r>
+              <a:rPr sz="2000" b="1">
+                <a:solidFill>
+                  <a:srgbClr val="14181F"/>
+                </a:solidFill>
+                <a:latin typeface="Arial"/>
+              </a:rPr>
+              <a:t>What the pilot needs</a:t>
+            </a:r>
+          </a:p>
+        </p:txBody>
+      </p:sp>
+      <p:sp>
+        <p:nvSpPr>
+          <p:cNvPr id="12" name="TextBox 11"/>
+          <p:cNvSpPr txBox="1"/>
+          <p:nvPr/>
+        </p:nvSpPr>
+        <p:spPr>
+          <a:xfrm>
+            <a:off x="8275320" y="2103120"/>
+            <a:ext cx="3383280" cy="3566160"/>
+          </a:xfrm>
+          <a:prstGeom prst="rect">
+            <a:avLst/>
+          </a:prstGeom>
+          <a:noFill/>
+        </p:spPr>
+        <p:txBody>
+          <a:bodyPr wrap="square" anchor="t" lIns="45720" rIns="45720" tIns="27432" bIns="27432">
+            <a:spAutoFit/>
+          </a:bodyPr>
+          <a:lstStyle/>
+          <a:p>
+            <a:pPr algn="l">
+              <a:lnSpc>
+                <a:spcPct val="110000"/>
+              </a:lnSpc>
+              <a:spcAft>
+                <a:spcPts val="880"/>
+              </a:spcAft>
+            </a:pPr>
+            <a:r>
+              <a:rPr sz="1600" b="1">
+                <a:solidFill>
+                  <a:srgbClr val="14181F"/>
+                </a:solidFill>
+                <a:latin typeface="Arial"/>
+              </a:rPr>
+              <a:t>•  </a:t>
+            </a:r>
+            <a:r>
+              <a:rPr sz="1600" b="0">
+                <a:solidFill>
+                  <a:srgbClr val="14181F"/>
+                </a:solidFill>
+                <a:latin typeface="Arial"/>
+              </a:rPr>
+              <a:t>An opt-in question at booking: today none of the studio's customers are eligible</a:t>
+            </a:r>
+          </a:p>
+          <a:p>
+            <a:pPr algn="l">
+              <a:lnSpc>
+                <a:spcPct val="110000"/>
+              </a:lnSpc>
+              <a:spcAft>
+                <a:spcPts val="880"/>
+              </a:spcAft>
+            </a:pPr>
+            <a:r>
+              <a:rPr sz="1600" b="1">
+                <a:solidFill>
+                  <a:srgbClr val="14181F"/>
+                </a:solidFill>
+                <a:latin typeface="Arial"/>
+              </a:rPr>
+              <a:t>•  </a:t>
+            </a:r>
+            <a:r>
+              <a:rPr sz="1600" b="0">
+                <a:solidFill>
+                  <a:srgbClr val="14181F"/>
+                </a:solidFill>
+                <a:latin typeface="Arial"/>
+              </a:rPr>
+              <a:t>Inbound routing: STOP and replies forwarded to ReKindle</a:t>
+            </a:r>
+          </a:p>
+          <a:p>
+            <a:pPr algn="l">
+              <a:lnSpc>
+                <a:spcPct val="110000"/>
+              </a:lnSpc>
+              <a:spcAft>
+                <a:spcPts val="880"/>
+              </a:spcAft>
+            </a:pPr>
+            <a:r>
+              <a:rPr sz="1600" b="1">
+                <a:solidFill>
+                  <a:srgbClr val="14181F"/>
+                </a:solidFill>
+                <a:latin typeface="Arial"/>
+              </a:rPr>
+              <a:t>•  </a:t>
+            </a:r>
+            <a:r>
+              <a:rPr sz="1600" b="0">
+                <a:solidFill>
+                  <a:srgbClr val="14181F"/>
+                </a:solidFill>
+                <a:latin typeface="Arial"/>
+              </a:rPr>
+              <a:t>An approved Marketing template (rk_reengage_v1)</a:t>
+            </a:r>
+          </a:p>
+          <a:p>
+            <a:pPr algn="l">
+              <a:lnSpc>
+                <a:spcPct val="110000"/>
+              </a:lnSpc>
+              <a:spcAft>
+                <a:spcPts val="880"/>
+              </a:spcAft>
+            </a:pPr>
+            <a:r>
+              <a:rPr sz="1600" b="1">
+                <a:solidFill>
+                  <a:srgbClr val="14181F"/>
+                </a:solidFill>
+                <a:latin typeface="Arial"/>
+              </a:rPr>
+              <a:t>•  </a:t>
+            </a:r>
+            <a:r>
+              <a:rPr sz="1600" b="0">
+                <a:solidFill>
+                  <a:srgbClr val="14181F"/>
+                </a:solidFill>
+                <a:latin typeface="Arial"/>
+              </a:rPr>
+              <a:t>Venkat's real prices and approved offers</a:t>
+            </a:r>
+          </a:p>
+        </p:txBody>
+      </p:sp>
+      <p:sp>
+        <p:nvSpPr>
+          <p:cNvPr id="13" name="TextBox 12"/>
+          <p:cNvSpPr txBox="1"/>
+          <p:nvPr/>
+        </p:nvSpPr>
+        <p:spPr>
+          <a:xfrm>
+            <a:off x="457200" y="5943600"/>
+            <a:ext cx="11247120" cy="548640"/>
+          </a:xfrm>
+          <a:prstGeom prst="rect">
+            <a:avLst/>
+          </a:prstGeom>
+          <a:noFill/>
+        </p:spPr>
+        <p:txBody>
+          <a:bodyPr wrap="square" anchor="t" lIns="45720" rIns="45720" tIns="27432" bIns="27432">
+            <a:spAutoFit/>
+          </a:bodyPr>
+          <a:lstStyle/>
+          <a:p>
+            <a:pPr algn="l">
+              <a:lnSpc>
+                <a:spcPct val="110000"/>
+              </a:lnSpc>
+              <a:spcAft>
+                <a:spcPts val="585"/>
+              </a:spcAft>
+            </a:pPr>
+            <a:r>
+              <a:rPr sz="1300" b="0">
+                <a:solidFill>
+                  <a:srgbClr val="5B6472"/>
+                </a:solidFill>
+                <a:latin typeface="Arial"/>
+              </a:rPr>
+              <a:t>Reviewed against the Baby Trails repo. Details and proposed changes: docs/BABYTRAILS_INTEGRATION.md</a:t>
+            </a:r>
+          </a:p>
+        </p:txBody>
+      </p:sp>
+    </p:spTree>
+  </p:cSld>
+  <p:clrMapOvr>
+    <a:masterClrMapping/>
+  </p:clrMapOvr>
+</p:sld>
+</file>
+
+<file path=ppt/slides/slide9.xml><?xml version="1.0" encoding="utf-8"?>
+<p:sld xmlns:a="http://schemas.openxmlformats.org/drawingml/2006/main" xmlns:p="http://schemas.openxmlformats.org/presentationml/2006/main" xmlns:r="http://schemas.openxmlformats.org/officeDocument/2006/relationships">
+  <p:cSld>
+    <p:spTree>
+      <p:nvGrpSpPr>
+        <p:cNvPr id="1" name=""/>
+        <p:cNvGrpSpPr/>
+        <p:nvPr/>
+      </p:nvGrpSpPr>
+      <p:grpSpPr/>
+      <p:pic>
+        <p:nvPicPr>
+          <p:cNvPr id="2" name="Picture 1" descr="header.png"/>
+          <p:cNvPicPr>
+            <a:picLocks noChangeAspect="1"/>
+          </p:cNvPicPr>
+          <p:nvPr/>
+        </p:nvPicPr>
+        <p:blipFill>
+          <a:blip r:embed="rId2"/>
+          <a:stretch>
+            <a:fillRect/>
+          </a:stretch>
+        </p:blipFill>
+        <p:spPr>
+          <a:xfrm>
+            <a:off x="0" y="0"/>
+            <a:ext cx="12191695" cy="676639"/>
+          </a:xfrm>
+          <a:prstGeom prst="rect">
+            <a:avLst/>
+          </a:prstGeom>
+        </p:spPr>
+      </p:pic>
+      <p:sp>
+        <p:nvSpPr>
+          <p:cNvPr id="3" name="TextBox 2"/>
+          <p:cNvSpPr txBox="1"/>
+          <p:nvPr/>
+        </p:nvSpPr>
+        <p:spPr>
+          <a:xfrm>
+            <a:off x="457200" y="749808"/>
+            <a:ext cx="11247120" cy="548640"/>
+          </a:xfrm>
+          <a:prstGeom prst="rect">
+            <a:avLst/>
+          </a:prstGeom>
+          <a:noFill/>
+        </p:spPr>
+        <p:txBody>
+          <a:bodyPr wrap="square" anchor="t" lIns="45720" rIns="45720" tIns="27432" bIns="27432">
+            <a:spAutoFit/>
+          </a:bodyPr>
+          <a:lstStyle/>
+          <a:p>
+            <a:pPr algn="l">
+              <a:lnSpc>
+                <a:spcPct val="110000"/>
+              </a:lnSpc>
+              <a:spcAft>
+                <a:spcPts val="1260"/>
+              </a:spcAft>
+            </a:pPr>
+            <a:r>
+              <a:rPr sz="2800" b="1">
+                <a:solidFill>
+                  <a:srgbClr val="14181F"/>
+                </a:solidFill>
+                <a:latin typeface="Arial"/>
+              </a:rPr>
               <a:t>Technologies used in the solution</a:t>
             </a:r>
           </a:p>
@@ -8640,7 +9742,7 @@
         </p:nvGraphicFramePr>
         <p:xfrm>
           <a:off x="457200" y="1417320"/>
-          <a:ext cx="11247120" cy="4937760"/>
+          <a:ext cx="11247120" cy="5029200"/>
         </p:xfrm>
         <a:graphic>
           <a:graphicData uri="http://schemas.openxmlformats.org/drawingml/2006/table">
@@ -8652,7 +9754,7 @@
                 <a:gridCol w="2926080"/>
                 <a:gridCol w="8321040"/>
               </a:tblGrid>
-              <a:tr h="617220">
+              <a:tr h="558800">
                 <a:tc>
                   <a:txBody>
                     <a:bodyPr/>
@@ -8698,14 +9800,14 @@
                   </a:tcPr>
                 </a:tc>
               </a:tr>
-              <a:tr h="617220">
+              <a:tr h="558800">
                 <a:tc>
                   <a:txBody>
                     <a:bodyPr/>
                     <a:lstStyle/>
                     <a:p>
                       <a:r>
-                        <a:rPr sz="1400" b="1">
+                        <a:rPr sz="1300" b="1">
                           <a:solidFill>
                             <a:srgbClr val="14181F"/>
                           </a:solidFill>
@@ -8727,7 +9829,7 @@
                     <a:lstStyle/>
                     <a:p>
                       <a:r>
-                        <a:rPr sz="1400" b="0">
+                        <a:rPr sz="1300" b="0">
                           <a:solidFill>
                             <a:srgbClr val="14181F"/>
                           </a:solidFill>
@@ -8744,14 +9846,14 @@
                   </a:tcPr>
                 </a:tc>
               </a:tr>
-              <a:tr h="617220">
+              <a:tr h="558800">
                 <a:tc>
                   <a:txBody>
                     <a:bodyPr/>
                     <a:lstStyle/>
                     <a:p>
                       <a:r>
-                        <a:rPr sz="1400" b="1">
+                        <a:rPr sz="1300" b="1">
                           <a:solidFill>
                             <a:srgbClr val="14181F"/>
                           </a:solidFill>
@@ -8773,7 +9875,7 @@
                     <a:lstStyle/>
                     <a:p>
                       <a:r>
-                        <a:rPr sz="1400" b="0">
+                        <a:rPr sz="1300" b="0">
                           <a:solidFill>
                             <a:srgbClr val="14181F"/>
                           </a:solidFill>
@@ -8790,14 +9892,14 @@
                   </a:tcPr>
                 </a:tc>
               </a:tr>
-              <a:tr h="617220">
+              <a:tr h="558800">
                 <a:tc>
                   <a:txBody>
                     <a:bodyPr/>
                     <a:lstStyle/>
                     <a:p>
                       <a:r>
-                        <a:rPr sz="1400" b="1">
+                        <a:rPr sz="1300" b="1">
                           <a:solidFill>
                             <a:srgbClr val="14181F"/>
                           </a:solidFill>
@@ -8819,7 +9921,7 @@
                     <a:lstStyle/>
                     <a:p>
                       <a:r>
-                        <a:rPr sz="1400" b="0">
+                        <a:rPr sz="1300" b="0">
                           <a:solidFill>
                             <a:srgbClr val="14181F"/>
                           </a:solidFill>
@@ -8836,14 +9938,14 @@
                   </a:tcPr>
                 </a:tc>
               </a:tr>
-              <a:tr h="617220">
+              <a:tr h="558800">
                 <a:tc>
                   <a:txBody>
                     <a:bodyPr/>
                     <a:lstStyle/>
                     <a:p>
                       <a:r>
-                        <a:rPr sz="1400" b="1">
+                        <a:rPr sz="1300" b="1">
                           <a:solidFill>
                             <a:srgbClr val="14181F"/>
                           </a:solidFill>
@@ -8865,7 +9967,7 @@
                     <a:lstStyle/>
                     <a:p>
                       <a:r>
-                        <a:rPr sz="1400" b="0">
+                        <a:rPr sz="1300" b="0">
                           <a:solidFill>
                             <a:srgbClr val="14181F"/>
                           </a:solidFill>
@@ -8882,14 +9984,14 @@
                   </a:tcPr>
                 </a:tc>
               </a:tr>
-              <a:tr h="617220">
+              <a:tr h="558800">
                 <a:tc>
                   <a:txBody>
                     <a:bodyPr/>
                     <a:lstStyle/>
                     <a:p>
                       <a:r>
-                        <a:rPr sz="1400" b="1">
+                        <a:rPr sz="1300" b="1">
                           <a:solidFill>
                             <a:srgbClr val="14181F"/>
                           </a:solidFill>
@@ -8911,7 +10013,7 @@
                     <a:lstStyle/>
                     <a:p>
                       <a:r>
-                        <a:rPr sz="1400" b="0">
+                        <a:rPr sz="1300" b="0">
                           <a:solidFill>
                             <a:srgbClr val="14181F"/>
                           </a:solidFill>
@@ -8928,20 +10030,20 @@
                   </a:tcPr>
                 </a:tc>
               </a:tr>
-              <a:tr h="617220">
+              <a:tr h="558800">
                 <a:tc>
                   <a:txBody>
                     <a:bodyPr/>
                     <a:lstStyle/>
                     <a:p>
                       <a:r>
-                        <a:rPr sz="1400" b="1">
+                        <a:rPr sz="1300" b="1">
                           <a:solidFill>
                             <a:srgbClr val="14181F"/>
                           </a:solidFill>
                           <a:latin typeface="Arial"/>
                         </a:rPr>
-                        <a:t>Gmail API</a:t>
+                        <a:t>Baby Trails (existing)</a:t>
                       </a:r>
                     </a:p>
                   </a:txBody>
@@ -8957,13 +10059,13 @@
                     <a:lstStyle/>
                     <a:p>
                       <a:r>
-                        <a:rPr sz="1400" b="0">
+                        <a:rPr sz="1300" b="0">
                           <a:solidFill>
                             <a:srgbClr val="14181F"/>
                           </a:solidFill>
                           <a:latin typeface="Arial"/>
                         </a:rPr>
-                        <a:t>Email delivery with the opt-out line appended by the system</a:t>
+                        <a:t>Airtable bookings are the customer and order source; its server owns the WhatsApp number and webhook</a:t>
                       </a:r>
                     </a:p>
                   </a:txBody>
@@ -8974,20 +10076,20 @@
                   </a:tcPr>
                 </a:tc>
               </a:tr>
-              <a:tr h="617220">
+              <a:tr h="558800">
                 <a:tc>
                   <a:txBody>
                     <a:bodyPr/>
                     <a:lstStyle/>
                     <a:p>
                       <a:r>
-                        <a:rPr sz="1400" b="1">
+                        <a:rPr sz="1300" b="1">
                           <a:solidFill>
                             <a:srgbClr val="14181F"/>
                           </a:solidFill>
                           <a:latin typeface="Arial"/>
                         </a:rPr>
-                        <a:t>WhatsApp Cloud API</a:t>
+                        <a:t>Gmail API (optional)</a:t>
                       </a:r>
                     </a:p>
                   </a:txBody>
@@ -9003,7 +10105,53 @@
                     <a:lstStyle/>
                     <a:p>
                       <a:r>
-                        <a:rPr sz="1400" b="0">
+                        <a:rPr sz="1300" b="0">
+                          <a:solidFill>
+                            <a:srgbClr val="14181F"/>
+                          </a:solidFill>
+                          <a:latin typeface="Arial"/>
+                        </a:rPr>
+                        <a:t>Email with the system-added opt-out line; Baby Trails holds no emails today</a:t>
+                      </a:r>
+                    </a:p>
+                  </a:txBody>
+                  <a:tcPr anchor="ctr">
+                    <a:solidFill>
+                      <a:srgbClr val="F6F7F9"/>
+                    </a:solidFill>
+                  </a:tcPr>
+                </a:tc>
+              </a:tr>
+              <a:tr h="558800">
+                <a:tc>
+                  <a:txBody>
+                    <a:bodyPr/>
+                    <a:lstStyle/>
+                    <a:p>
+                      <a:r>
+                        <a:rPr sz="1300" b="1">
+                          <a:solidFill>
+                            <a:srgbClr val="14181F"/>
+                          </a:solidFill>
+                          <a:latin typeface="Arial"/>
+                        </a:rPr>
+                        <a:t>WhatsApp Cloud API</a:t>
+                      </a:r>
+                    </a:p>
+                  </a:txBody>
+                  <a:tcPr anchor="ctr">
+                    <a:solidFill>
+                      <a:srgbClr val="FFFFFF"/>
+                    </a:solidFill>
+                  </a:tcPr>
+                </a:tc>
+                <a:tc>
+                  <a:txBody>
+                    <a:bodyPr/>
+                    <a:lstStyle/>
+                    <a:p>
+                      <a:r>
+                        <a:rPr sz="1300" b="0">
                           <a:solidFill>
                             <a:srgbClr val="14181F"/>
                           </a:solidFill>
@@ -9015,7 +10163,7 @@
                   </a:txBody>
                   <a:tcPr anchor="ctr">
                     <a:solidFill>
-                      <a:srgbClr val="F6F7F9"/>
+                      <a:srgbClr val="FFFFFF"/>
                     </a:solidFill>
                   </a:tcPr>
                 </a:tc>
@@ -9024,340 +10172,6 @@
           </a:graphicData>
         </a:graphic>
       </p:graphicFrame>
-    </p:spTree>
-  </p:cSld>
-  <p:clrMapOvr>
-    <a:masterClrMapping/>
-  </p:clrMapOvr>
-</p:sld>
-</file>
-
-<file path=ppt/slides/slide9.xml><?xml version="1.0" encoding="utf-8"?>
-<p:sld xmlns:a="http://schemas.openxmlformats.org/drawingml/2006/main" xmlns:p="http://schemas.openxmlformats.org/presentationml/2006/main" xmlns:r="http://schemas.openxmlformats.org/officeDocument/2006/relationships">
-  <p:cSld>
-    <p:spTree>
-      <p:nvGrpSpPr>
-        <p:cNvPr id="1" name=""/>
-        <p:cNvGrpSpPr/>
-        <p:nvPr/>
-      </p:nvGrpSpPr>
-      <p:grpSpPr/>
-      <p:pic>
-        <p:nvPicPr>
-          <p:cNvPr id="2" name="Picture 1" descr="header.png"/>
-          <p:cNvPicPr>
-            <a:picLocks noChangeAspect="1"/>
-          </p:cNvPicPr>
-          <p:nvPr/>
-        </p:nvPicPr>
-        <p:blipFill>
-          <a:blip r:embed="rId2"/>
-          <a:stretch>
-            <a:fillRect/>
-          </a:stretch>
-        </p:blipFill>
-        <p:spPr>
-          <a:xfrm>
-            <a:off x="0" y="0"/>
-            <a:ext cx="12191695" cy="676639"/>
-          </a:xfrm>
-          <a:prstGeom prst="rect">
-            <a:avLst/>
-          </a:prstGeom>
-        </p:spPr>
-      </p:pic>
-      <p:sp>
-        <p:nvSpPr>
-          <p:cNvPr id="3" name="TextBox 2"/>
-          <p:cNvSpPr txBox="1"/>
-          <p:nvPr/>
-        </p:nvSpPr>
-        <p:spPr>
-          <a:xfrm>
-            <a:off x="457200" y="749808"/>
-            <a:ext cx="11247120" cy="548640"/>
-          </a:xfrm>
-          <a:prstGeom prst="rect">
-            <a:avLst/>
-          </a:prstGeom>
-          <a:noFill/>
-        </p:spPr>
-        <p:txBody>
-          <a:bodyPr wrap="square" anchor="t" lIns="45720" rIns="45720" tIns="27432" bIns="27432">
-            <a:spAutoFit/>
-          </a:bodyPr>
-          <a:lstStyle/>
-          <a:p>
-            <a:pPr algn="l">
-              <a:lnSpc>
-                <a:spcPct val="110000"/>
-              </a:lnSpc>
-              <a:spcAft>
-                <a:spcPts val="1260"/>
-              </a:spcAft>
-            </a:pPr>
-            <a:r>
-              <a:rPr sz="2800" b="1">
-                <a:solidFill>
-                  <a:srgbClr val="14181F"/>
-                </a:solidFill>
-                <a:latin typeface="Arial"/>
-              </a:rPr>
-              <a:t>Estimated implementation cost</a:t>
-            </a:r>
-          </a:p>
-        </p:txBody>
-      </p:sp>
-      <p:sp>
-        <p:nvSpPr>
-          <p:cNvPr id="4" name="TextBox 3"/>
-          <p:cNvSpPr txBox="1"/>
-          <p:nvPr/>
-        </p:nvSpPr>
-        <p:spPr>
-          <a:xfrm>
-            <a:off x="457200" y="1417320"/>
-            <a:ext cx="11247120" cy="914400"/>
-          </a:xfrm>
-          <a:prstGeom prst="rect">
-            <a:avLst/>
-          </a:prstGeom>
-          <a:noFill/>
-        </p:spPr>
-        <p:txBody>
-          <a:bodyPr wrap="square" anchor="t" lIns="45720" rIns="45720" tIns="27432" bIns="27432">
-            <a:spAutoFit/>
-          </a:bodyPr>
-          <a:lstStyle/>
-          <a:p>
-            <a:pPr algn="l">
-              <a:lnSpc>
-                <a:spcPct val="110000"/>
-              </a:lnSpc>
-              <a:spcAft>
-                <a:spcPts val="810"/>
-              </a:spcAft>
-            </a:pPr>
-            <a:r>
-              <a:rPr sz="1800" b="0">
-                <a:solidFill>
-                  <a:srgbClr val="14181F"/>
-                </a:solidFill>
-                <a:latin typeface="Arial"/>
-              </a:rPr>
-              <a:t>The MVP runs within Google Cloud hackathon credits. Every cost driver is consumption-based, and the design keeps the expensive part (the LLM) to one call per message, two at most.</a:t>
-            </a:r>
-          </a:p>
-        </p:txBody>
-      </p:sp>
-      <p:sp>
-        <p:nvSpPr>
-          <p:cNvPr id="5" name="TextBox 4"/>
-          <p:cNvSpPr txBox="1"/>
-          <p:nvPr/>
-        </p:nvSpPr>
-        <p:spPr>
-          <a:xfrm>
-            <a:off x="640080" y="2651760"/>
-            <a:ext cx="10789920" cy="3474720"/>
-          </a:xfrm>
-          <a:prstGeom prst="rect">
-            <a:avLst/>
-          </a:prstGeom>
-          <a:noFill/>
-        </p:spPr>
-        <p:txBody>
-          <a:bodyPr wrap="square" anchor="t" lIns="45720" rIns="45720" tIns="27432" bIns="27432">
-            <a:spAutoFit/>
-          </a:bodyPr>
-          <a:lstStyle/>
-          <a:p>
-            <a:pPr algn="l">
-              <a:lnSpc>
-                <a:spcPct val="110000"/>
-              </a:lnSpc>
-              <a:spcAft>
-                <a:spcPts val="950"/>
-              </a:spcAft>
-            </a:pPr>
-            <a:r>
-              <a:rPr sz="1900" b="1">
-                <a:solidFill>
-                  <a:srgbClr val="14181F"/>
-                </a:solidFill>
-                <a:latin typeface="Arial"/>
-              </a:rPr>
-              <a:t>•  </a:t>
-            </a:r>
-            <a:r>
-              <a:rPr sz="1900" b="1">
-                <a:solidFill>
-                  <a:srgbClr val="14181F"/>
-                </a:solidFill>
-                <a:latin typeface="Arial"/>
-              </a:rPr>
-              <a:t>Gemini on Vertex AI: </a:t>
-            </a:r>
-            <a:r>
-              <a:rPr sz="1900" b="0">
-                <a:solidFill>
-                  <a:srgbClr val="14181F"/>
-                </a:solidFill>
-                <a:latin typeface="Arial"/>
-              </a:rPr>
-              <a:t>scales with messages drafted; one call per message, plus one regeneration only when the guardrail blocks a draft</a:t>
-            </a:r>
-          </a:p>
-          <a:p>
-            <a:pPr algn="l">
-              <a:lnSpc>
-                <a:spcPct val="110000"/>
-              </a:lnSpc>
-              <a:spcAft>
-                <a:spcPts val="950"/>
-              </a:spcAft>
-            </a:pPr>
-            <a:r>
-              <a:rPr sz="1900" b="1">
-                <a:solidFill>
-                  <a:srgbClr val="14181F"/>
-                </a:solidFill>
-                <a:latin typeface="Arial"/>
-              </a:rPr>
-              <a:t>•  </a:t>
-            </a:r>
-            <a:r>
-              <a:rPr sz="1900" b="1">
-                <a:solidFill>
-                  <a:srgbClr val="14181F"/>
-                </a:solidFill>
-                <a:latin typeface="Arial"/>
-              </a:rPr>
-              <a:t>BigQuery: </a:t>
-            </a:r>
-            <a:r>
-              <a:rPr sz="1900" b="0">
-                <a:solidFill>
-                  <a:srgbClr val="14181F"/>
-                </a:solidFill>
-                <a:latin typeface="Arial"/>
-              </a:rPr>
-              <a:t>scales with customer records scanned; segmentation is one query per campaign run</a:t>
-            </a:r>
-          </a:p>
-          <a:p>
-            <a:pPr algn="l">
-              <a:lnSpc>
-                <a:spcPct val="110000"/>
-              </a:lnSpc>
-              <a:spcAft>
-                <a:spcPts val="950"/>
-              </a:spcAft>
-            </a:pPr>
-            <a:r>
-              <a:rPr sz="1900" b="1">
-                <a:solidFill>
-                  <a:srgbClr val="14181F"/>
-                </a:solidFill>
-                <a:latin typeface="Arial"/>
-              </a:rPr>
-              <a:t>•  </a:t>
-            </a:r>
-            <a:r>
-              <a:rPr sz="1900" b="1">
-                <a:solidFill>
-                  <a:srgbClr val="14181F"/>
-                </a:solidFill>
-                <a:latin typeface="Arial"/>
-              </a:rPr>
-              <a:t>Cloud Run: </a:t>
-            </a:r>
-            <a:r>
-              <a:rPr sz="1900" b="0">
-                <a:solidFill>
-                  <a:srgbClr val="14181F"/>
-                </a:solidFill>
-                <a:latin typeface="Arial"/>
-              </a:rPr>
-              <a:t>pay-per-request, scales to zero between campaigns</a:t>
-            </a:r>
-          </a:p>
-          <a:p>
-            <a:pPr algn="l">
-              <a:lnSpc>
-                <a:spcPct val="110000"/>
-              </a:lnSpc>
-              <a:spcAft>
-                <a:spcPts val="950"/>
-              </a:spcAft>
-            </a:pPr>
-            <a:r>
-              <a:rPr sz="1900" b="1">
-                <a:solidFill>
-                  <a:srgbClr val="14181F"/>
-                </a:solidFill>
-                <a:latin typeface="Arial"/>
-              </a:rPr>
-              <a:t>•  </a:t>
-            </a:r>
-            <a:r>
-              <a:rPr sz="1900" b="1">
-                <a:solidFill>
-                  <a:srgbClr val="14181F"/>
-                </a:solidFill>
-                <a:latin typeface="Arial"/>
-              </a:rPr>
-              <a:t>Firestore: </a:t>
-            </a:r>
-            <a:r>
-              <a:rPr sz="1900" b="0">
-                <a:solidFill>
-                  <a:srgbClr val="14181F"/>
-                </a:solidFill>
-                <a:latin typeface="Arial"/>
-              </a:rPr>
-              <a:t>scales with cockpit activity (drafts written, decisions made)</a:t>
-            </a:r>
-          </a:p>
-          <a:p>
-            <a:pPr algn="l">
-              <a:lnSpc>
-                <a:spcPct val="110000"/>
-              </a:lnSpc>
-              <a:spcAft>
-                <a:spcPts val="950"/>
-              </a:spcAft>
-            </a:pPr>
-            <a:r>
-              <a:rPr sz="1900" b="1">
-                <a:solidFill>
-                  <a:srgbClr val="14181F"/>
-                </a:solidFill>
-                <a:latin typeface="Arial"/>
-              </a:rPr>
-              <a:t>•  </a:t>
-            </a:r>
-            <a:r>
-              <a:rPr sz="1900" b="1">
-                <a:solidFill>
-                  <a:srgbClr val="14181F"/>
-                </a:solidFill>
-                <a:latin typeface="Arial"/>
-              </a:rPr>
-              <a:t>WhatsApp Business API: </a:t>
-            </a:r>
-            <a:r>
-              <a:rPr sz="1900" b="0">
-                <a:solidFill>
-                  <a:srgbClr val="14181F"/>
-                </a:solidFill>
-                <a:latin typeface="Arial"/>
-              </a:rPr>
-              <a:t>per-conversation fees from the provider; email via Gmail API has no per-message fee</a:t>
-            </a:r>
-          </a:p>
-        </p:txBody>
-      </p:sp>
     </p:spTree>
   </p:cSld>
   <p:clrMapOvr>

</xml_diff>

<commit_message>
Reword deck: POC with pilot planned, not live customers
</commit_message>
<xml_diff>
--- a/docs/deck/ReKindle_AI_Builder_Cup.pptx
+++ b/docs/deck/ReKindle_AI_Builder_Cup.pptx
@@ -4620,7 +4620,7 @@
                 </a:solidFill>
                 <a:latin typeface="Arial"/>
               </a:rPr>
-              <a:t>69 automated tests cover the Baby Trails adapter, segmentation, opt-in and STOP, the guardrail, routing and the approval API.</a:t>
+              <a:t>70 automated tests cover the Baby Trails adapter, segmentation, opt-in and STOP, the guardrail, routing and the approval API.</a:t>
             </a:r>
           </a:p>
         </p:txBody>
@@ -4717,7 +4717,7 @@
                 </a:solidFill>
                 <a:latin typeface="Arial"/>
               </a:rPr>
-              <a:t>This tests the guardrail with our own corruption set on synthetic data, not Gemini's real output or real customers. Pilot metrics (auto-send rate, approval latency, time saved, recovered revenue) will be measured on Babytrail's data at the Nov 6 prototype evaluation and replace the simulated figures.</a:t>
+              <a:t>This tests the guardrail with our own corruption set on synthetic data, not Gemini's real output or real customers. Pilot metrics (auto-send rate, approval latency, time saved, recovered revenue) are planned for the pilot with Baby Trails and will replace the simulated figures.</a:t>
             </a:r>
           </a:p>
         </p:txBody>
@@ -6693,7 +6693,7 @@
                 </a:solidFill>
                 <a:latin typeface="Arial"/>
               </a:rPr>
-              <a:t>Built on Google Cloud: BigQuery, Gemini on Vertex AI, Cloud Run, Firestore, Looker Studio. Pilot partner: Babytrail Photography (Baby Trails), whose booking system already runs on GCP. A studio is the hardest test of personalization because every message touches a family milestone; the same engine generalizes to apparel, D2C, salons and clinics.</a:t>
+              <a:t>Built on Google Cloud: BigQuery, Gemini on Vertex AI, Cloud Run, Firestore, Looker Studio. POC built with Babytrail Photography (Baby Trails), whose booking system already runs on GCP; a pilot is planned. A studio is the hardest test of personalization because every message touches a family milestone; the same engine generalizes to apparel, D2C, salons and clinics.</a:t>
             </a:r>
           </a:p>
         </p:txBody>

</xml_diff>